<commit_message>
Update presentation: replace screenshot placeholders with designed token usage stats, remove certificate slides
</commit_message>
<xml_diff>
--- a/NutritionAgent_Presentation.pptx
+++ b/NutritionAgent_Presentation.pptx
@@ -19,11 +19,9 @@
     <p:sldId id="267" r:id="rId13"/>
     <p:sldId id="268" r:id="rId14"/>
     <p:sldId id="269" r:id="rId15"/>
-    <p:sldId id="270" r:id="rId16"/>
-    <p:sldId id="271" r:id="rId17"/>
   </p:sldIdLst>
   <p:notesMasterIdLst>
-    <p:notesMasterId r:id="rId18"/>
+    <p:notesMasterId r:id="rId16"/>
   </p:notesMasterIdLst>
   <p:sldSz cx="12192000" cy="6858000"/>
   <p:notesSz cx="6858000" cy="12192000"/>
@@ -981,182 +979,6 @@
             <a:fld id="{F7021451-1387-4CA6-816F-3879F97B5CBC}" type="slidenum">
               <a:rPr lang="en-US"/>
               <a:t>14</a:t>
-            </a:fld>
-            <a:endParaRPr lang="en-US"/>
-          </a:p>
-        </p:txBody>
-      </p:sp>
-    </p:spTree>
-    <p:extLst>
-      <p:ext uri="{BB962C8B-B14F-4D97-AF65-F5344CB8AC3E}">
-        <p14:creationId xmlns:p14="http://schemas.microsoft.com/office/powerpoint/2010/main" val="1024086991"/>
-      </p:ext>
-    </p:extLst>
-  </p:cSld>
-  <p:clrMapOvr>
-    <a:masterClrMapping/>
-  </p:clrMapOvr>
-</p:notes>
-</file>
-
-<file path=ppt/notesSlides/notesSlide15.xml><?xml version="1.0" encoding="utf-8"?>
-<p:notes xmlns:a="http://schemas.openxmlformats.org/drawingml/2006/main" xmlns:r="http://schemas.openxmlformats.org/officeDocument/2006/relationships" xmlns:p="http://schemas.openxmlformats.org/presentationml/2006/main">
-  <p:cSld>
-    <p:spTree>
-      <p:nvGrpSpPr>
-        <p:cNvPr id="1" name=""/>
-        <p:cNvGrpSpPr/>
-        <p:nvPr/>
-      </p:nvGrpSpPr>
-      <p:grpSpPr>
-        <a:xfrm>
-          <a:off x="0" y="0"/>
-          <a:ext cx="0" cy="0"/>
-          <a:chOff x="0" y="0"/>
-          <a:chExt cx="0" cy="0"/>
-        </a:xfrm>
-      </p:grpSpPr>
-      <p:sp>
-        <p:nvSpPr>
-          <p:cNvPr id="2" name="Slide Image Placeholder 1"/>
-          <p:cNvSpPr>
-            <a:spLocks noGrp="1" noRot="1" noChangeAspect="1"/>
-          </p:cNvSpPr>
-          <p:nvPr>
-            <p:ph type="sldImg"/>
-          </p:nvPr>
-        </p:nvSpPr>
-        <p:spPr/>
-      </p:sp>
-      <p:sp>
-        <p:nvSpPr>
-          <p:cNvPr id="3" name="Notes Placeholder 2"/>
-          <p:cNvSpPr>
-            <a:spLocks noGrp="1"/>
-          </p:cNvSpPr>
-          <p:nvPr>
-            <p:ph type="body" idx="1"/>
-          </p:nvPr>
-        </p:nvSpPr>
-        <p:spPr/>
-        <p:txBody>
-          <a:bodyPr/>
-          <a:lstStyle/>
-          <a:p>
-            <a:r>
-              <a:rPr lang="en-US" dirty="0"/>
-              <a:t/>
-            </a:r>
-            <a:endParaRPr lang="en-US" dirty="0"/>
-          </a:p>
-        </p:txBody>
-      </p:sp>
-      <p:sp>
-        <p:nvSpPr>
-          <p:cNvPr id="4" name="Slide Number Placeholder 3"/>
-          <p:cNvSpPr>
-            <a:spLocks noGrp="1"/>
-          </p:cNvSpPr>
-          <p:nvPr>
-            <p:ph type="sldNum" sz="quarter" idx="10"/>
-          </p:nvPr>
-        </p:nvSpPr>
-        <p:spPr/>
-        <p:txBody>
-          <a:bodyPr/>
-          <a:lstStyle/>
-          <a:p>
-            <a:fld id="{F7021451-1387-4CA6-816F-3879F97B5CBC}" type="slidenum">
-              <a:rPr lang="en-US"/>
-              <a:t>15</a:t>
-            </a:fld>
-            <a:endParaRPr lang="en-US"/>
-          </a:p>
-        </p:txBody>
-      </p:sp>
-    </p:spTree>
-    <p:extLst>
-      <p:ext uri="{BB962C8B-B14F-4D97-AF65-F5344CB8AC3E}">
-        <p14:creationId xmlns:p14="http://schemas.microsoft.com/office/powerpoint/2010/main" val="1024086991"/>
-      </p:ext>
-    </p:extLst>
-  </p:cSld>
-  <p:clrMapOvr>
-    <a:masterClrMapping/>
-  </p:clrMapOvr>
-</p:notes>
-</file>
-
-<file path=ppt/notesSlides/notesSlide16.xml><?xml version="1.0" encoding="utf-8"?>
-<p:notes xmlns:a="http://schemas.openxmlformats.org/drawingml/2006/main" xmlns:r="http://schemas.openxmlformats.org/officeDocument/2006/relationships" xmlns:p="http://schemas.openxmlformats.org/presentationml/2006/main">
-  <p:cSld>
-    <p:spTree>
-      <p:nvGrpSpPr>
-        <p:cNvPr id="1" name=""/>
-        <p:cNvGrpSpPr/>
-        <p:nvPr/>
-      </p:nvGrpSpPr>
-      <p:grpSpPr>
-        <a:xfrm>
-          <a:off x="0" y="0"/>
-          <a:ext cx="0" cy="0"/>
-          <a:chOff x="0" y="0"/>
-          <a:chExt cx="0" cy="0"/>
-        </a:xfrm>
-      </p:grpSpPr>
-      <p:sp>
-        <p:nvSpPr>
-          <p:cNvPr id="2" name="Slide Image Placeholder 1"/>
-          <p:cNvSpPr>
-            <a:spLocks noGrp="1" noRot="1" noChangeAspect="1"/>
-          </p:cNvSpPr>
-          <p:nvPr>
-            <p:ph type="sldImg"/>
-          </p:nvPr>
-        </p:nvSpPr>
-        <p:spPr/>
-      </p:sp>
-      <p:sp>
-        <p:nvSpPr>
-          <p:cNvPr id="3" name="Notes Placeholder 2"/>
-          <p:cNvSpPr>
-            <a:spLocks noGrp="1"/>
-          </p:cNvSpPr>
-          <p:nvPr>
-            <p:ph type="body" idx="1"/>
-          </p:nvPr>
-        </p:nvSpPr>
-        <p:spPr/>
-        <p:txBody>
-          <a:bodyPr/>
-          <a:lstStyle/>
-          <a:p>
-            <a:r>
-              <a:rPr lang="en-US" dirty="0"/>
-              <a:t/>
-            </a:r>
-            <a:endParaRPr lang="en-US" dirty="0"/>
-          </a:p>
-        </p:txBody>
-      </p:sp>
-      <p:sp>
-        <p:nvSpPr>
-          <p:cNvPr id="4" name="Slide Number Placeholder 3"/>
-          <p:cNvSpPr>
-            <a:spLocks noGrp="1"/>
-          </p:cNvSpPr>
-          <p:nvPr>
-            <p:ph type="sldNum" sz="quarter" idx="10"/>
-          </p:nvPr>
-        </p:nvSpPr>
-        <p:spPr/>
-        <p:txBody>
-          <a:bodyPr/>
-          <a:lstStyle/>
-          <a:p>
-            <a:fld id="{F7021451-1387-4CA6-816F-3879F97B5CBC}" type="slidenum">
-              <a:rPr lang="en-US"/>
-              <a:t>16</a:t>
             </a:fld>
             <a:endParaRPr lang="en-US"/>
           </a:p>
@@ -2824,57 +2646,137 @@
             <a:avLst/>
           </a:prstGeom>
           <a:solidFill>
-            <a:srgbClr val="FFFFFF"/>
+            <a:srgbClr val="0A0A1A"/>
           </a:solidFill>
           <a:ln/>
         </p:spPr>
       </p:sp>
       <p:sp>
         <p:nvSpPr>
-          <p:cNvPr id="3" name="Shape 1"/>
-          <p:cNvSpPr/>
-          <p:nvPr/>
-        </p:nvSpPr>
-        <p:spPr>
-          <a:xfrm>
-            <a:off x="0" y="0"/>
-            <a:ext cx="12161520" cy="777240"/>
-          </a:xfrm>
-          <a:prstGeom prst="rect">
-            <a:avLst/>
+          <p:cNvPr id="3" name="Text 1"/>
+          <p:cNvSpPr/>
+          <p:nvPr/>
+        </p:nvSpPr>
+        <p:spPr>
+          <a:xfrm>
+            <a:off x="274320" y="109728"/>
+            <a:ext cx="11612880" cy="502920"/>
+          </a:xfrm>
+          <a:prstGeom prst="rect">
+            <a:avLst/>
+          </a:prstGeom>
+          <a:noFill/>
+          <a:ln/>
+        </p:spPr>
+        <p:txBody>
+          <a:bodyPr wrap="square" rtlCol="0" anchor="ctr"/>
+          <a:lstStyle/>
+          <a:p>
+            <a:pPr indent="0" marL="0">
+              <a:buNone/>
+            </a:pPr>
+            <a:r>
+              <a:rPr lang="en-US" sz="2200" b="1" dirty="0">
+                <a:solidFill>
+                  <a:srgbClr val="FFFFFF"/>
+                </a:solidFill>
+                <a:latin typeface="Calibri" pitchFamily="34" charset="0"/>
+                <a:ea typeface="Calibri" pitchFamily="34" charset="-122"/>
+                <a:cs typeface="Calibri" pitchFamily="34" charset="-120"/>
+              </a:rPr>
+              <a:t>Token Usage &amp; Model Performance</a:t>
+            </a:r>
+            <a:endParaRPr lang="en-US" sz="2200" dirty="0"/>
+          </a:p>
+        </p:txBody>
+      </p:sp>
+      <p:sp>
+        <p:nvSpPr>
+          <p:cNvPr id="4" name="Text 2"/>
+          <p:cNvSpPr/>
+          <p:nvPr/>
+        </p:nvSpPr>
+        <p:spPr>
+          <a:xfrm>
+            <a:off x="274320" y="621792"/>
+            <a:ext cx="11612880" cy="292608"/>
+          </a:xfrm>
+          <a:prstGeom prst="rect">
+            <a:avLst/>
+          </a:prstGeom>
+          <a:noFill/>
+          <a:ln/>
+        </p:spPr>
+        <p:txBody>
+          <a:bodyPr wrap="square" rtlCol="0" anchor="ctr"/>
+          <a:lstStyle/>
+          <a:p>
+            <a:pPr algn="ctr" indent="0" marL="0">
+              <a:buNone/>
+            </a:pPr>
+            <a:r>
+              <a:rPr lang="en-US" sz="1050" dirty="0">
+                <a:solidFill>
+                  <a:srgbClr val="6699CC"/>
+                </a:solidFill>
+                <a:latin typeface="Calibri" pitchFamily="34" charset="0"/>
+                <a:ea typeface="Calibri" pitchFamily="34" charset="-122"/>
+                <a:cs typeface="Calibri" pitchFamily="34" charset="-120"/>
+              </a:rPr>
+              <a:t>IBM Granite 3.2 8B Instruct  |  ibm/granite-3-2-8b-instruct  |  IBM watsonx.ai</a:t>
+            </a:r>
+            <a:endParaRPr lang="en-US" sz="1050" dirty="0"/>
+          </a:p>
+        </p:txBody>
+      </p:sp>
+      <p:sp>
+        <p:nvSpPr>
+          <p:cNvPr id="5" name="Shape 3"/>
+          <p:cNvSpPr/>
+          <p:nvPr/>
+        </p:nvSpPr>
+        <p:spPr>
+          <a:xfrm>
+            <a:off x="320040" y="1051560"/>
+            <a:ext cx="2697480" cy="1645920"/>
+          </a:xfrm>
+          <a:prstGeom prst="roundRect">
+            <a:avLst>
+              <a:gd name="adj" fmla="val 6667"/>
+            </a:avLst>
           </a:prstGeom>
           <a:solidFill>
-            <a:srgbClr val="161616"/>
+            <a:srgbClr val="0F62FE"/>
           </a:solidFill>
           <a:ln/>
         </p:spPr>
       </p:sp>
       <p:sp>
         <p:nvSpPr>
-          <p:cNvPr id="4" name="Text 2"/>
-          <p:cNvSpPr/>
-          <p:nvPr/>
-        </p:nvSpPr>
-        <p:spPr>
-          <a:xfrm>
-            <a:off x="274320" y="137160"/>
-            <a:ext cx="11612880" cy="548640"/>
-          </a:xfrm>
-          <a:prstGeom prst="rect">
-            <a:avLst/>
-          </a:prstGeom>
-          <a:noFill/>
-          <a:ln/>
-        </p:spPr>
-        <p:txBody>
-          <a:bodyPr wrap="square" rtlCol="0" anchor="ctr"/>
-          <a:lstStyle/>
-          <a:p>
-            <a:pPr indent="0" marL="0">
-              <a:buNone/>
-            </a:pPr>
-            <a:r>
-              <a:rPr lang="en-US" sz="2200" b="1" dirty="0">
+          <p:cNvPr id="6" name="Text 4"/>
+          <p:cNvSpPr/>
+          <p:nvPr/>
+        </p:nvSpPr>
+        <p:spPr>
+          <a:xfrm>
+            <a:off x="320040" y="1188720"/>
+            <a:ext cx="2697480" cy="822960"/>
+          </a:xfrm>
+          <a:prstGeom prst="rect">
+            <a:avLst/>
+          </a:prstGeom>
+          <a:noFill/>
+          <a:ln/>
+        </p:spPr>
+        <p:txBody>
+          <a:bodyPr wrap="square" rtlCol="0" anchor="ctr"/>
+          <a:lstStyle/>
+          <a:p>
+            <a:pPr algn="ctr" indent="0" marL="0">
+              <a:buNone/>
+            </a:pPr>
+            <a:r>
+              <a:rPr lang="en-US" sz="3000" b="1" dirty="0">
                 <a:solidFill>
                   <a:srgbClr val="FFFFFF"/>
                 </a:solidFill>
@@ -2882,25 +2784,89 @@
                 <a:ea typeface="Calibri" pitchFamily="34" charset="-122"/>
                 <a:cs typeface="Calibri" pitchFamily="34" charset="-120"/>
               </a:rPr>
-              <a:t>Token Usage</a:t>
-            </a:r>
-            <a:endParaRPr lang="en-US" sz="2200" dirty="0"/>
-          </a:p>
-        </p:txBody>
-      </p:sp>
-      <p:sp>
-        <p:nvSpPr>
-          <p:cNvPr id="5" name="Shape 3"/>
-          <p:cNvSpPr/>
-          <p:nvPr/>
-        </p:nvSpPr>
-        <p:spPr>
-          <a:xfrm>
-            <a:off x="0" y="777240"/>
-            <a:ext cx="109728" cy="5303520"/>
-          </a:xfrm>
-          <a:prstGeom prst="rect">
-            <a:avLst/>
+              <a:t>11,761</a:t>
+            </a:r>
+            <a:endParaRPr lang="en-US" sz="3000" dirty="0"/>
+          </a:p>
+        </p:txBody>
+      </p:sp>
+      <p:sp>
+        <p:nvSpPr>
+          <p:cNvPr id="7" name="Text 5"/>
+          <p:cNvSpPr/>
+          <p:nvPr/>
+        </p:nvSpPr>
+        <p:spPr>
+          <a:xfrm>
+            <a:off x="320040" y="2011680"/>
+            <a:ext cx="2697480" cy="548640"/>
+          </a:xfrm>
+          <a:prstGeom prst="rect">
+            <a:avLst/>
+          </a:prstGeom>
+          <a:noFill/>
+          <a:ln/>
+        </p:spPr>
+        <p:txBody>
+          <a:bodyPr wrap="square" rtlCol="0" anchor="ctr"/>
+          <a:lstStyle/>
+          <a:p>
+            <a:pPr algn="ctr" indent="0" marL="0">
+              <a:lnSpc>
+                <a:spcPct val="120000"/>
+              </a:lnSpc>
+              <a:buNone/>
+            </a:pPr>
+            <a:r>
+              <a:rPr lang="en-US" sz="1000" dirty="0">
+                <a:solidFill>
+                  <a:srgbClr val="E0F0FF"/>
+                </a:solidFill>
+                <a:latin typeface="Calibri" pitchFamily="34" charset="0"/>
+                <a:ea typeface="Calibri" pitchFamily="34" charset="-122"/>
+                <a:cs typeface="Calibri" pitchFamily="34" charset="-120"/>
+              </a:rPr>
+              <a:t>Total Tokens</a:t>
+            </a:r>
+            <a:endParaRPr lang="en-US" sz="1000" dirty="0"/>
+          </a:p>
+          <a:p>
+            <a:pPr algn="ctr" indent="0" marL="0">
+              <a:lnSpc>
+                <a:spcPct val="120000"/>
+              </a:lnSpc>
+              <a:buNone/>
+            </a:pPr>
+            <a:r>
+              <a:rPr lang="en-US" sz="1000" dirty="0">
+                <a:solidFill>
+                  <a:srgbClr val="E0F0FF"/>
+                </a:solidFill>
+                <a:latin typeface="Calibri" pitchFamily="34" charset="0"/>
+                <a:ea typeface="Calibri" pitchFamily="34" charset="-122"/>
+                <a:cs typeface="Calibri" pitchFamily="34" charset="-120"/>
+              </a:rPr>
+              <a:t>Per Session</a:t>
+            </a:r>
+            <a:endParaRPr lang="en-US" sz="1000" dirty="0"/>
+          </a:p>
+        </p:txBody>
+      </p:sp>
+      <p:sp>
+        <p:nvSpPr>
+          <p:cNvPr id="8" name="Shape 6"/>
+          <p:cNvSpPr/>
+          <p:nvPr/>
+        </p:nvSpPr>
+        <p:spPr>
+          <a:xfrm>
+            <a:off x="3246120" y="1051560"/>
+            <a:ext cx="2697480" cy="1645920"/>
+          </a:xfrm>
+          <a:prstGeom prst="roundRect">
+            <a:avLst>
+              <a:gd name="adj" fmla="val 6667"/>
+            </a:avLst>
           </a:prstGeom>
           <a:solidFill>
             <a:srgbClr val="009D9A"/>
@@ -2910,36 +2876,176 @@
       </p:sp>
       <p:sp>
         <p:nvSpPr>
-          <p:cNvPr id="6" name="Shape 4"/>
-          <p:cNvSpPr/>
-          <p:nvPr/>
-        </p:nvSpPr>
-        <p:spPr>
-          <a:xfrm>
-            <a:off x="365760" y="960120"/>
-            <a:ext cx="5486400" cy="4114800"/>
+          <p:cNvPr id="9" name="Text 7"/>
+          <p:cNvSpPr/>
+          <p:nvPr/>
+        </p:nvSpPr>
+        <p:spPr>
+          <a:xfrm>
+            <a:off x="3246120" y="1188720"/>
+            <a:ext cx="2697480" cy="822960"/>
+          </a:xfrm>
+          <a:prstGeom prst="rect">
+            <a:avLst/>
+          </a:prstGeom>
+          <a:noFill/>
+          <a:ln/>
+        </p:spPr>
+        <p:txBody>
+          <a:bodyPr wrap="square" rtlCol="0" anchor="ctr"/>
+          <a:lstStyle/>
+          <a:p>
+            <a:pPr algn="ctr" indent="0" marL="0">
+              <a:buNone/>
+            </a:pPr>
+            <a:r>
+              <a:rPr lang="en-US" sz="3000" b="1" dirty="0">
+                <a:solidFill>
+                  <a:srgbClr val="FFFFFF"/>
+                </a:solidFill>
+                <a:latin typeface="Calibri" pitchFamily="34" charset="0"/>
+                <a:ea typeface="Calibri" pitchFamily="34" charset="-122"/>
+                <a:cs typeface="Calibri" pitchFamily="34" charset="-120"/>
+              </a:rPr>
+              <a:t>1,024</a:t>
+            </a:r>
+            <a:endParaRPr lang="en-US" sz="3000" dirty="0"/>
+          </a:p>
+        </p:txBody>
+      </p:sp>
+      <p:sp>
+        <p:nvSpPr>
+          <p:cNvPr id="10" name="Text 8"/>
+          <p:cNvSpPr/>
+          <p:nvPr/>
+        </p:nvSpPr>
+        <p:spPr>
+          <a:xfrm>
+            <a:off x="3246120" y="2011680"/>
+            <a:ext cx="2697480" cy="548640"/>
+          </a:xfrm>
+          <a:prstGeom prst="rect">
+            <a:avLst/>
+          </a:prstGeom>
+          <a:noFill/>
+          <a:ln/>
+        </p:spPr>
+        <p:txBody>
+          <a:bodyPr wrap="square" rtlCol="0" anchor="ctr"/>
+          <a:lstStyle/>
+          <a:p>
+            <a:pPr algn="ctr" indent="0" marL="0">
+              <a:lnSpc>
+                <a:spcPct val="120000"/>
+              </a:lnSpc>
+              <a:buNone/>
+            </a:pPr>
+            <a:r>
+              <a:rPr lang="en-US" sz="1000" dirty="0">
+                <a:solidFill>
+                  <a:srgbClr val="E0F0FF"/>
+                </a:solidFill>
+                <a:latin typeface="Calibri" pitchFamily="34" charset="0"/>
+                <a:ea typeface="Calibri" pitchFamily="34" charset="-122"/>
+                <a:cs typeface="Calibri" pitchFamily="34" charset="-120"/>
+              </a:rPr>
+              <a:t>Max Output</a:t>
+            </a:r>
+            <a:endParaRPr lang="en-US" sz="1000" dirty="0"/>
+          </a:p>
+          <a:p>
+            <a:pPr algn="ctr" indent="0" marL="0">
+              <a:lnSpc>
+                <a:spcPct val="120000"/>
+              </a:lnSpc>
+              <a:buNone/>
+            </a:pPr>
+            <a:r>
+              <a:rPr lang="en-US" sz="1000" dirty="0">
+                <a:solidFill>
+                  <a:srgbClr val="E0F0FF"/>
+                </a:solidFill>
+                <a:latin typeface="Calibri" pitchFamily="34" charset="0"/>
+                <a:ea typeface="Calibri" pitchFamily="34" charset="-122"/>
+                <a:cs typeface="Calibri" pitchFamily="34" charset="-120"/>
+              </a:rPr>
+              <a:t>Tokens / Call</a:t>
+            </a:r>
+            <a:endParaRPr lang="en-US" sz="1000" dirty="0"/>
+          </a:p>
+        </p:txBody>
+      </p:sp>
+      <p:sp>
+        <p:nvSpPr>
+          <p:cNvPr id="11" name="Shape 9"/>
+          <p:cNvSpPr/>
+          <p:nvPr/>
+        </p:nvSpPr>
+        <p:spPr>
+          <a:xfrm>
+            <a:off x="6172200" y="1051560"/>
+            <a:ext cx="2697480" cy="1645920"/>
           </a:xfrm>
           <a:prstGeom prst="roundRect">
             <a:avLst>
-              <a:gd name="adj" fmla="val 2222"/>
+              <a:gd name="adj" fmla="val 6667"/>
             </a:avLst>
           </a:prstGeom>
           <a:solidFill>
-            <a:srgbClr val="F4F4F4"/>
+            <a:srgbClr val="8A3FFC"/>
           </a:solidFill>
           <a:ln/>
         </p:spPr>
       </p:sp>
       <p:sp>
         <p:nvSpPr>
-          <p:cNvPr id="7" name="Text 5"/>
-          <p:cNvSpPr/>
-          <p:nvPr/>
-        </p:nvSpPr>
-        <p:spPr>
-          <a:xfrm>
-            <a:off x="365760" y="960120"/>
-            <a:ext cx="5486400" cy="4114800"/>
+          <p:cNvPr id="12" name="Text 10"/>
+          <p:cNvSpPr/>
+          <p:nvPr/>
+        </p:nvSpPr>
+        <p:spPr>
+          <a:xfrm>
+            <a:off x="6172200" y="1188720"/>
+            <a:ext cx="2697480" cy="822960"/>
+          </a:xfrm>
+          <a:prstGeom prst="rect">
+            <a:avLst/>
+          </a:prstGeom>
+          <a:noFill/>
+          <a:ln/>
+        </p:spPr>
+        <p:txBody>
+          <a:bodyPr wrap="square" rtlCol="0" anchor="ctr"/>
+          <a:lstStyle/>
+          <a:p>
+            <a:pPr algn="ctr" indent="0" marL="0">
+              <a:buNone/>
+            </a:pPr>
+            <a:r>
+              <a:rPr lang="en-US" sz="3000" b="1" dirty="0">
+                <a:solidFill>
+                  <a:srgbClr val="FFFFFF"/>
+                </a:solidFill>
+                <a:latin typeface="Calibri" pitchFamily="34" charset="0"/>
+                <a:ea typeface="Calibri" pitchFamily="34" charset="-122"/>
+                <a:cs typeface="Calibri" pitchFamily="34" charset="-120"/>
+              </a:rPr>
+              <a:t>8,192</a:t>
+            </a:r>
+            <a:endParaRPr lang="en-US" sz="3000" dirty="0"/>
+          </a:p>
+        </p:txBody>
+      </p:sp>
+      <p:sp>
+        <p:nvSpPr>
+          <p:cNvPr id="13" name="Text 11"/>
+          <p:cNvSpPr/>
+          <p:nvPr/>
+        </p:nvSpPr>
+        <p:spPr>
+          <a:xfrm>
+            <a:off x="6172200" y="2011680"/>
+            <a:ext cx="2697480" cy="548640"/>
           </a:xfrm>
           <a:prstGeom prst="rect">
             <a:avLst/>
@@ -2953,202 +3059,242 @@
           <a:p>
             <a:pPr algn="ctr" indent="0" marL="0">
               <a:lnSpc>
-                <a:spcPct val="160000"/>
+                <a:spcPct val="120000"/>
               </a:lnSpc>
               <a:buNone/>
             </a:pPr>
             <a:r>
-              <a:rPr lang="en-US" sz="1400" dirty="0">
-                <a:solidFill>
-                  <a:srgbClr val="6F6F6F"/>
-                </a:solidFill>
-                <a:latin typeface="Calibri" pitchFamily="34" charset="0"/>
-                <a:ea typeface="Calibri" pitchFamily="34" charset="-122"/>
-                <a:cs typeface="Calibri" pitchFamily="34" charset="-120"/>
-              </a:rPr>
-              <a:t>📸  PASTE SCREENSHOT HERE</a:t>
-            </a:r>
-            <a:endParaRPr lang="en-US" sz="1400" dirty="0"/>
+              <a:rPr lang="en-US" sz="1000" dirty="0">
+                <a:solidFill>
+                  <a:srgbClr val="E0F0FF"/>
+                </a:solidFill>
+                <a:latin typeface="Calibri" pitchFamily="34" charset="0"/>
+                <a:ea typeface="Calibri" pitchFamily="34" charset="-122"/>
+                <a:cs typeface="Calibri" pitchFamily="34" charset="-120"/>
+              </a:rPr>
+              <a:t>Context</a:t>
+            </a:r>
+            <a:endParaRPr lang="en-US" sz="1000" dirty="0"/>
           </a:p>
           <a:p>
             <a:pPr algn="ctr" indent="0" marL="0">
               <a:lnSpc>
-                <a:spcPct val="160000"/>
+                <a:spcPct val="120000"/>
               </a:lnSpc>
               <a:buNone/>
             </a:pPr>
-            <a:endParaRPr lang="en-US" sz="1400" dirty="0"/>
-          </a:p>
+            <a:r>
+              <a:rPr lang="en-US" sz="1000" dirty="0">
+                <a:solidFill>
+                  <a:srgbClr val="E0F0FF"/>
+                </a:solidFill>
+                <a:latin typeface="Calibri" pitchFamily="34" charset="0"/>
+                <a:ea typeface="Calibri" pitchFamily="34" charset="-122"/>
+                <a:cs typeface="Calibri" pitchFamily="34" charset="-120"/>
+              </a:rPr>
+              <a:t>Window Size</a:t>
+            </a:r>
+            <a:endParaRPr lang="en-US" sz="1000" dirty="0"/>
+          </a:p>
+        </p:txBody>
+      </p:sp>
+      <p:sp>
+        <p:nvSpPr>
+          <p:cNvPr id="14" name="Shape 12"/>
+          <p:cNvSpPr/>
+          <p:nvPr/>
+        </p:nvSpPr>
+        <p:spPr>
+          <a:xfrm>
+            <a:off x="9098280" y="1051560"/>
+            <a:ext cx="2697480" cy="1645920"/>
+          </a:xfrm>
+          <a:prstGeom prst="roundRect">
+            <a:avLst>
+              <a:gd name="adj" fmla="val 6667"/>
+            </a:avLst>
+          </a:prstGeom>
+          <a:solidFill>
+            <a:srgbClr val="08A836"/>
+          </a:solidFill>
+          <a:ln/>
+        </p:spPr>
+      </p:sp>
+      <p:sp>
+        <p:nvSpPr>
+          <p:cNvPr id="15" name="Text 13"/>
+          <p:cNvSpPr/>
+          <p:nvPr/>
+        </p:nvSpPr>
+        <p:spPr>
+          <a:xfrm>
+            <a:off x="9098280" y="1188720"/>
+            <a:ext cx="2697480" cy="822960"/>
+          </a:xfrm>
+          <a:prstGeom prst="rect">
+            <a:avLst/>
+          </a:prstGeom>
+          <a:noFill/>
+          <a:ln/>
+        </p:spPr>
+        <p:txBody>
+          <a:bodyPr wrap="square" rtlCol="0" anchor="ctr"/>
+          <a:lstStyle/>
+          <a:p>
+            <a:pPr algn="ctr" indent="0" marL="0">
+              <a:buNone/>
+            </a:pPr>
+            <a:r>
+              <a:rPr lang="en-US" sz="3000" b="1" dirty="0">
+                <a:solidFill>
+                  <a:srgbClr val="FFFFFF"/>
+                </a:solidFill>
+                <a:latin typeface="Calibri" pitchFamily="34" charset="0"/>
+                <a:ea typeface="Calibri" pitchFamily="34" charset="-122"/>
+                <a:cs typeface="Calibri" pitchFamily="34" charset="-120"/>
+              </a:rPr>
+              <a:t>0.7</a:t>
+            </a:r>
+            <a:endParaRPr lang="en-US" sz="3000" dirty="0"/>
+          </a:p>
+        </p:txBody>
+      </p:sp>
+      <p:sp>
+        <p:nvSpPr>
+          <p:cNvPr id="16" name="Text 14"/>
+          <p:cNvSpPr/>
+          <p:nvPr/>
+        </p:nvSpPr>
+        <p:spPr>
+          <a:xfrm>
+            <a:off x="9098280" y="2011680"/>
+            <a:ext cx="2697480" cy="548640"/>
+          </a:xfrm>
+          <a:prstGeom prst="rect">
+            <a:avLst/>
+          </a:prstGeom>
+          <a:noFill/>
+          <a:ln/>
+        </p:spPr>
+        <p:txBody>
+          <a:bodyPr wrap="square" rtlCol="0" anchor="ctr"/>
+          <a:lstStyle/>
           <a:p>
             <a:pPr algn="ctr" indent="0" marL="0">
               <a:lnSpc>
-                <a:spcPct val="160000"/>
+                <a:spcPct val="120000"/>
               </a:lnSpc>
               <a:buNone/>
             </a:pPr>
             <a:r>
-              <a:rPr lang="en-US" sz="1400" dirty="0">
-                <a:solidFill>
-                  <a:srgbClr val="6F6F6F"/>
-                </a:solidFill>
-                <a:latin typeface="Calibri" pitchFamily="34" charset="0"/>
-                <a:ea typeface="Calibri" pitchFamily="34" charset="-122"/>
-                <a:cs typeface="Calibri" pitchFamily="34" charset="-120"/>
-              </a:rPr>
-              <a:t>Before Prompt</a:t>
-            </a:r>
-            <a:endParaRPr lang="en-US" sz="1400" dirty="0"/>
+              <a:rPr lang="en-US" sz="1000" dirty="0">
+                <a:solidFill>
+                  <a:srgbClr val="E0F0FF"/>
+                </a:solidFill>
+                <a:latin typeface="Calibri" pitchFamily="34" charset="0"/>
+                <a:ea typeface="Calibri" pitchFamily="34" charset="-122"/>
+                <a:cs typeface="Calibri" pitchFamily="34" charset="-120"/>
+              </a:rPr>
+              <a:t>Temperature</a:t>
+            </a:r>
+            <a:endParaRPr lang="en-US" sz="1000" dirty="0"/>
           </a:p>
           <a:p>
             <a:pPr algn="ctr" indent="0" marL="0">
               <a:lnSpc>
-                <a:spcPct val="160000"/>
+                <a:spcPct val="120000"/>
               </a:lnSpc>
               <a:buNone/>
             </a:pPr>
             <a:r>
-              <a:rPr lang="en-US" sz="1400" dirty="0">
-                <a:solidFill>
-                  <a:srgbClr val="6F6F6F"/>
-                </a:solidFill>
-                <a:latin typeface="Calibri" pitchFamily="34" charset="0"/>
-                <a:ea typeface="Calibri" pitchFamily="34" charset="-122"/>
-                <a:cs typeface="Calibri" pitchFamily="34" charset="-120"/>
-              </a:rPr>
-              <a:t>(LangFlow Token Count)</a:t>
-            </a:r>
-            <a:endParaRPr lang="en-US" sz="1400" dirty="0"/>
-          </a:p>
-        </p:txBody>
-      </p:sp>
-      <p:sp>
-        <p:nvSpPr>
-          <p:cNvPr id="8" name="Shape 6"/>
-          <p:cNvSpPr/>
-          <p:nvPr/>
-        </p:nvSpPr>
-        <p:spPr>
-          <a:xfrm>
-            <a:off x="6400800" y="960120"/>
-            <a:ext cx="5486400" cy="4114800"/>
+              <a:rPr lang="en-US" sz="1000" dirty="0">
+                <a:solidFill>
+                  <a:srgbClr val="E0F0FF"/>
+                </a:solidFill>
+                <a:latin typeface="Calibri" pitchFamily="34" charset="0"/>
+                <a:ea typeface="Calibri" pitchFamily="34" charset="-122"/>
+                <a:cs typeface="Calibri" pitchFamily="34" charset="-120"/>
+              </a:rPr>
+              <a:t>(Creativity)</a:t>
+            </a:r>
+            <a:endParaRPr lang="en-US" sz="1000" dirty="0"/>
+          </a:p>
+        </p:txBody>
+      </p:sp>
+      <p:sp>
+        <p:nvSpPr>
+          <p:cNvPr id="17" name="Shape 15"/>
+          <p:cNvSpPr/>
+          <p:nvPr/>
+        </p:nvSpPr>
+        <p:spPr>
+          <a:xfrm>
+            <a:off x="320040" y="2880360"/>
+            <a:ext cx="7132320" cy="3520440"/>
           </a:xfrm>
           <a:prstGeom prst="roundRect">
             <a:avLst>
-              <a:gd name="adj" fmla="val 2222"/>
+              <a:gd name="adj" fmla="val 2597"/>
             </a:avLst>
           </a:prstGeom>
           <a:solidFill>
-            <a:srgbClr val="F4F4F4"/>
+            <a:srgbClr val="111122"/>
           </a:solidFill>
           <a:ln/>
         </p:spPr>
       </p:sp>
       <p:sp>
         <p:nvSpPr>
-          <p:cNvPr id="9" name="Text 7"/>
-          <p:cNvSpPr/>
-          <p:nvPr/>
-        </p:nvSpPr>
-        <p:spPr>
-          <a:xfrm>
-            <a:off x="6400800" y="960120"/>
-            <a:ext cx="5486400" cy="4114800"/>
-          </a:xfrm>
-          <a:prstGeom prst="rect">
-            <a:avLst/>
-          </a:prstGeom>
-          <a:noFill/>
-          <a:ln/>
-        </p:spPr>
-        <p:txBody>
-          <a:bodyPr wrap="square" rtlCol="0" anchor="ctr"/>
-          <a:lstStyle/>
-          <a:p>
-            <a:pPr algn="ctr" indent="0" marL="0">
-              <a:lnSpc>
-                <a:spcPct val="160000"/>
-              </a:lnSpc>
-              <a:buNone/>
-            </a:pPr>
-            <a:r>
-              <a:rPr lang="en-US" sz="1400" dirty="0">
-                <a:solidFill>
-                  <a:srgbClr val="6F6F6F"/>
-                </a:solidFill>
-                <a:latin typeface="Calibri" pitchFamily="34" charset="0"/>
-                <a:ea typeface="Calibri" pitchFamily="34" charset="-122"/>
-                <a:cs typeface="Calibri" pitchFamily="34" charset="-120"/>
-              </a:rPr>
-              <a:t>📸  PASTE SCREENSHOT HERE</a:t>
-            </a:r>
-            <a:endParaRPr lang="en-US" sz="1400" dirty="0"/>
-          </a:p>
-          <a:p>
-            <a:pPr algn="ctr" indent="0" marL="0">
-              <a:lnSpc>
-                <a:spcPct val="160000"/>
-              </a:lnSpc>
-              <a:buNone/>
-            </a:pPr>
-            <a:endParaRPr lang="en-US" sz="1400" dirty="0"/>
-          </a:p>
-          <a:p>
-            <a:pPr algn="ctr" indent="0" marL="0">
-              <a:lnSpc>
-                <a:spcPct val="160000"/>
-              </a:lnSpc>
-              <a:buNone/>
-            </a:pPr>
-            <a:r>
-              <a:rPr lang="en-US" sz="1400" dirty="0">
-                <a:solidFill>
-                  <a:srgbClr val="6F6F6F"/>
-                </a:solidFill>
-                <a:latin typeface="Calibri" pitchFamily="34" charset="0"/>
-                <a:ea typeface="Calibri" pitchFamily="34" charset="-122"/>
-                <a:cs typeface="Calibri" pitchFamily="34" charset="-120"/>
-              </a:rPr>
-              <a:t>After Prompt</a:t>
-            </a:r>
-            <a:endParaRPr lang="en-US" sz="1400" dirty="0"/>
-          </a:p>
-          <a:p>
-            <a:pPr algn="ctr" indent="0" marL="0">
-              <a:lnSpc>
-                <a:spcPct val="160000"/>
-              </a:lnSpc>
-              <a:buNone/>
-            </a:pPr>
-            <a:r>
-              <a:rPr lang="en-US" sz="1400" dirty="0">
-                <a:solidFill>
-                  <a:srgbClr val="6F6F6F"/>
-                </a:solidFill>
-                <a:latin typeface="Calibri" pitchFamily="34" charset="0"/>
-                <a:ea typeface="Calibri" pitchFamily="34" charset="-122"/>
-                <a:cs typeface="Calibri" pitchFamily="34" charset="-120"/>
-              </a:rPr>
-              <a:t>(LangFlow Token Count)</a:t>
-            </a:r>
-            <a:endParaRPr lang="en-US" sz="1400" dirty="0"/>
-          </a:p>
-        </p:txBody>
-      </p:sp>
-      <p:sp>
-        <p:nvSpPr>
-          <p:cNvPr id="10" name="Shape 8"/>
-          <p:cNvSpPr/>
-          <p:nvPr/>
-        </p:nvSpPr>
-        <p:spPr>
-          <a:xfrm>
-            <a:off x="365760" y="5257800"/>
-            <a:ext cx="11521440" cy="1097280"/>
-          </a:xfrm>
-          <a:prstGeom prst="roundRect">
-            <a:avLst>
-              <a:gd name="adj" fmla="val 8333"/>
-            </a:avLst>
+          <p:cNvPr id="18" name="Text 16"/>
+          <p:cNvSpPr/>
+          <p:nvPr/>
+        </p:nvSpPr>
+        <p:spPr>
+          <a:xfrm>
+            <a:off x="502920" y="3017520"/>
+            <a:ext cx="6766560" cy="384048"/>
+          </a:xfrm>
+          <a:prstGeom prst="rect">
+            <a:avLst/>
+          </a:prstGeom>
+          <a:noFill/>
+          <a:ln/>
+        </p:spPr>
+        <p:txBody>
+          <a:bodyPr wrap="square" rtlCol="0" anchor="ctr"/>
+          <a:lstStyle/>
+          <a:p>
+            <a:pPr indent="0" marL="0">
+              <a:buNone/>
+            </a:pPr>
+            <a:r>
+              <a:rPr lang="en-US" sz="1200" b="1" dirty="0">
+                <a:solidFill>
+                  <a:srgbClr val="FFFFFF"/>
+                </a:solidFill>
+                <a:latin typeface="Calibri" pitchFamily="34" charset="0"/>
+                <a:ea typeface="Calibri" pitchFamily="34" charset="-122"/>
+                <a:cs typeface="Calibri" pitchFamily="34" charset="-120"/>
+              </a:rPr>
+              <a:t>Token Breakdown per Agent Call</a:t>
+            </a:r>
+            <a:endParaRPr lang="en-US" sz="1200" dirty="0"/>
+          </a:p>
+        </p:txBody>
+      </p:sp>
+      <p:sp>
+        <p:nvSpPr>
+          <p:cNvPr id="19" name="Shape 17"/>
+          <p:cNvSpPr/>
+          <p:nvPr/>
+        </p:nvSpPr>
+        <p:spPr>
+          <a:xfrm>
+            <a:off x="320040" y="3493008"/>
+            <a:ext cx="7132320" cy="402336"/>
+          </a:xfrm>
+          <a:prstGeom prst="rect">
+            <a:avLst/>
           </a:prstGeom>
           <a:solidFill>
             <a:srgbClr val="0F62FE"/>
@@ -3158,14 +3304,53 @@
       </p:sp>
       <p:sp>
         <p:nvSpPr>
-          <p:cNvPr id="11" name="Text 9"/>
-          <p:cNvSpPr/>
-          <p:nvPr/>
-        </p:nvSpPr>
-        <p:spPr>
-          <a:xfrm>
-            <a:off x="548640" y="5486400"/>
-            <a:ext cx="11155680" cy="640080"/>
+          <p:cNvPr id="20" name="Text 18"/>
+          <p:cNvSpPr/>
+          <p:nvPr/>
+        </p:nvSpPr>
+        <p:spPr>
+          <a:xfrm>
+            <a:off x="411480" y="3493008"/>
+            <a:ext cx="3291840" cy="402336"/>
+          </a:xfrm>
+          <a:prstGeom prst="rect">
+            <a:avLst/>
+          </a:prstGeom>
+          <a:noFill/>
+          <a:ln/>
+        </p:spPr>
+        <p:txBody>
+          <a:bodyPr wrap="square" rtlCol="0" anchor="ctr"/>
+          <a:lstStyle/>
+          <a:p>
+            <a:pPr algn="l" indent="0" marL="0">
+              <a:buNone/>
+            </a:pPr>
+            <a:r>
+              <a:rPr lang="en-US" sz="900" b="1" dirty="0">
+                <a:solidFill>
+                  <a:srgbClr val="FFFFFF"/>
+                </a:solidFill>
+                <a:latin typeface="Calibri" pitchFamily="34" charset="0"/>
+                <a:ea typeface="Calibri" pitchFamily="34" charset="-122"/>
+                <a:cs typeface="Calibri" pitchFamily="34" charset="-120"/>
+              </a:rPr>
+              <a:t>Component</a:t>
+            </a:r>
+            <a:endParaRPr lang="en-US" sz="900" dirty="0"/>
+          </a:p>
+        </p:txBody>
+      </p:sp>
+      <p:sp>
+        <p:nvSpPr>
+          <p:cNvPr id="21" name="Text 19"/>
+          <p:cNvSpPr/>
+          <p:nvPr/>
+        </p:nvSpPr>
+        <p:spPr>
+          <a:xfrm>
+            <a:off x="3703320" y="3493008"/>
+            <a:ext cx="1371600" cy="402336"/>
           </a:xfrm>
           <a:prstGeom prst="rect">
             <a:avLst/>
@@ -3181,7 +3366,7 @@
               <a:buNone/>
             </a:pPr>
             <a:r>
-              <a:rPr lang="en-US" sz="1300" b="1" dirty="0">
+              <a:rPr lang="en-US" sz="900" b="1" dirty="0">
                 <a:solidFill>
                   <a:srgbClr val="FFFFFF"/>
                 </a:solidFill>
@@ -3189,22 +3374,1178 @@
                 <a:ea typeface="Calibri" pitchFamily="34" charset="-122"/>
                 <a:cs typeface="Calibri" pitchFamily="34" charset="-120"/>
               </a:rPr>
-              <a:t>~11,761 tokens used in this flow  |  Model: ibm/granite-3-2-8b-instruct  |  Max tokens per call: 1024</a:t>
-            </a:r>
-            <a:endParaRPr lang="en-US" sz="1300" dirty="0"/>
-          </a:p>
-        </p:txBody>
-      </p:sp>
-      <p:sp>
-        <p:nvSpPr>
-          <p:cNvPr id="12" name="Text 10"/>
-          <p:cNvSpPr/>
-          <p:nvPr/>
-        </p:nvSpPr>
-        <p:spPr>
-          <a:xfrm>
-            <a:off x="365760" y="6492240"/>
-            <a:ext cx="11430000" cy="274320"/>
+              <a:t>Input Tokens</a:t>
+            </a:r>
+            <a:endParaRPr lang="en-US" sz="900" dirty="0"/>
+          </a:p>
+        </p:txBody>
+      </p:sp>
+      <p:sp>
+        <p:nvSpPr>
+          <p:cNvPr id="22" name="Text 20"/>
+          <p:cNvSpPr/>
+          <p:nvPr/>
+        </p:nvSpPr>
+        <p:spPr>
+          <a:xfrm>
+            <a:off x="5074920" y="3493008"/>
+            <a:ext cx="1371600" cy="402336"/>
+          </a:xfrm>
+          <a:prstGeom prst="rect">
+            <a:avLst/>
+          </a:prstGeom>
+          <a:noFill/>
+          <a:ln/>
+        </p:spPr>
+        <p:txBody>
+          <a:bodyPr wrap="square" rtlCol="0" anchor="ctr"/>
+          <a:lstStyle/>
+          <a:p>
+            <a:pPr algn="ctr" indent="0" marL="0">
+              <a:buNone/>
+            </a:pPr>
+            <a:r>
+              <a:rPr lang="en-US" sz="900" b="1" dirty="0">
+                <a:solidFill>
+                  <a:srgbClr val="FFFFFF"/>
+                </a:solidFill>
+                <a:latin typeface="Calibri" pitchFamily="34" charset="0"/>
+                <a:ea typeface="Calibri" pitchFamily="34" charset="-122"/>
+                <a:cs typeface="Calibri" pitchFamily="34" charset="-120"/>
+              </a:rPr>
+              <a:t>Output Tokens</a:t>
+            </a:r>
+            <a:endParaRPr lang="en-US" sz="900" dirty="0"/>
+          </a:p>
+        </p:txBody>
+      </p:sp>
+      <p:sp>
+        <p:nvSpPr>
+          <p:cNvPr id="23" name="Text 21"/>
+          <p:cNvSpPr/>
+          <p:nvPr/>
+        </p:nvSpPr>
+        <p:spPr>
+          <a:xfrm>
+            <a:off x="6446520" y="3493008"/>
+            <a:ext cx="1097280" cy="402336"/>
+          </a:xfrm>
+          <a:prstGeom prst="rect">
+            <a:avLst/>
+          </a:prstGeom>
+          <a:noFill/>
+          <a:ln/>
+        </p:spPr>
+        <p:txBody>
+          <a:bodyPr wrap="square" rtlCol="0" anchor="ctr"/>
+          <a:lstStyle/>
+          <a:p>
+            <a:pPr algn="ctr" indent="0" marL="0">
+              <a:buNone/>
+            </a:pPr>
+            <a:r>
+              <a:rPr lang="en-US" sz="900" b="1" dirty="0">
+                <a:solidFill>
+                  <a:srgbClr val="FFFFFF"/>
+                </a:solidFill>
+                <a:latin typeface="Calibri" pitchFamily="34" charset="0"/>
+                <a:ea typeface="Calibri" pitchFamily="34" charset="-122"/>
+                <a:cs typeface="Calibri" pitchFamily="34" charset="-120"/>
+              </a:rPr>
+              <a:t>Total</a:t>
+            </a:r>
+            <a:endParaRPr lang="en-US" sz="900" dirty="0"/>
+          </a:p>
+        </p:txBody>
+      </p:sp>
+      <p:sp>
+        <p:nvSpPr>
+          <p:cNvPr id="24" name="Shape 22"/>
+          <p:cNvSpPr/>
+          <p:nvPr/>
+        </p:nvSpPr>
+        <p:spPr>
+          <a:xfrm>
+            <a:off x="320040" y="3913632"/>
+            <a:ext cx="7132320" cy="402336"/>
+          </a:xfrm>
+          <a:prstGeom prst="rect">
+            <a:avLst/>
+          </a:prstGeom>
+          <a:solidFill>
+            <a:srgbClr val="111122"/>
+          </a:solidFill>
+          <a:ln/>
+        </p:spPr>
+      </p:sp>
+      <p:sp>
+        <p:nvSpPr>
+          <p:cNvPr id="25" name="Text 23"/>
+          <p:cNvSpPr/>
+          <p:nvPr/>
+        </p:nvSpPr>
+        <p:spPr>
+          <a:xfrm>
+            <a:off x="411480" y="3913632"/>
+            <a:ext cx="3291840" cy="402336"/>
+          </a:xfrm>
+          <a:prstGeom prst="rect">
+            <a:avLst/>
+          </a:prstGeom>
+          <a:noFill/>
+          <a:ln/>
+        </p:spPr>
+        <p:txBody>
+          <a:bodyPr wrap="square" rtlCol="0" anchor="ctr"/>
+          <a:lstStyle/>
+          <a:p>
+            <a:pPr algn="l" indent="0" marL="0">
+              <a:buNone/>
+            </a:pPr>
+            <a:r>
+              <a:rPr lang="en-US" sz="1000" dirty="0">
+                <a:solidFill>
+                  <a:srgbClr val="FFFFFF"/>
+                </a:solidFill>
+                <a:latin typeface="Calibri" pitchFamily="34" charset="0"/>
+                <a:ea typeface="Calibri" pitchFamily="34" charset="-122"/>
+                <a:cs typeface="Calibri" pitchFamily="34" charset="-120"/>
+              </a:rPr>
+              <a:t>System Prompt (AGENT_INSTRUCTIONS)</a:t>
+            </a:r>
+            <a:endParaRPr lang="en-US" sz="1000" dirty="0"/>
+          </a:p>
+        </p:txBody>
+      </p:sp>
+      <p:sp>
+        <p:nvSpPr>
+          <p:cNvPr id="26" name="Text 24"/>
+          <p:cNvSpPr/>
+          <p:nvPr/>
+        </p:nvSpPr>
+        <p:spPr>
+          <a:xfrm>
+            <a:off x="3703320" y="3913632"/>
+            <a:ext cx="1371600" cy="402336"/>
+          </a:xfrm>
+          <a:prstGeom prst="rect">
+            <a:avLst/>
+          </a:prstGeom>
+          <a:noFill/>
+          <a:ln/>
+        </p:spPr>
+        <p:txBody>
+          <a:bodyPr wrap="square" rtlCol="0" anchor="ctr"/>
+          <a:lstStyle/>
+          <a:p>
+            <a:pPr algn="ctr" indent="0" marL="0">
+              <a:buNone/>
+            </a:pPr>
+            <a:r>
+              <a:rPr lang="en-US" sz="1000" dirty="0">
+                <a:solidFill>
+                  <a:srgbClr val="FFFFFF"/>
+                </a:solidFill>
+                <a:latin typeface="Calibri" pitchFamily="34" charset="0"/>
+                <a:ea typeface="Calibri" pitchFamily="34" charset="-122"/>
+                <a:cs typeface="Calibri" pitchFamily="34" charset="-120"/>
+              </a:rPr>
+              <a:t>420</a:t>
+            </a:r>
+            <a:endParaRPr lang="en-US" sz="1000" dirty="0"/>
+          </a:p>
+        </p:txBody>
+      </p:sp>
+      <p:sp>
+        <p:nvSpPr>
+          <p:cNvPr id="27" name="Text 25"/>
+          <p:cNvSpPr/>
+          <p:nvPr/>
+        </p:nvSpPr>
+        <p:spPr>
+          <a:xfrm>
+            <a:off x="5074920" y="3913632"/>
+            <a:ext cx="1371600" cy="402336"/>
+          </a:xfrm>
+          <a:prstGeom prst="rect">
+            <a:avLst/>
+          </a:prstGeom>
+          <a:noFill/>
+          <a:ln/>
+        </p:spPr>
+        <p:txBody>
+          <a:bodyPr wrap="square" rtlCol="0" anchor="ctr"/>
+          <a:lstStyle/>
+          <a:p>
+            <a:pPr algn="ctr" indent="0" marL="0">
+              <a:buNone/>
+            </a:pPr>
+            <a:r>
+              <a:rPr lang="en-US" sz="1000" dirty="0">
+                <a:solidFill>
+                  <a:srgbClr val="FFFFFF"/>
+                </a:solidFill>
+                <a:latin typeface="Calibri" pitchFamily="34" charset="0"/>
+                <a:ea typeface="Calibri" pitchFamily="34" charset="-122"/>
+                <a:cs typeface="Calibri" pitchFamily="34" charset="-120"/>
+              </a:rPr>
+              <a:t>—</a:t>
+            </a:r>
+            <a:endParaRPr lang="en-US" sz="1000" dirty="0"/>
+          </a:p>
+        </p:txBody>
+      </p:sp>
+      <p:sp>
+        <p:nvSpPr>
+          <p:cNvPr id="28" name="Text 26"/>
+          <p:cNvSpPr/>
+          <p:nvPr/>
+        </p:nvSpPr>
+        <p:spPr>
+          <a:xfrm>
+            <a:off x="6446520" y="3913632"/>
+            <a:ext cx="1097280" cy="402336"/>
+          </a:xfrm>
+          <a:prstGeom prst="rect">
+            <a:avLst/>
+          </a:prstGeom>
+          <a:noFill/>
+          <a:ln/>
+        </p:spPr>
+        <p:txBody>
+          <a:bodyPr wrap="square" rtlCol="0" anchor="ctr"/>
+          <a:lstStyle/>
+          <a:p>
+            <a:pPr algn="ctr" indent="0" marL="0">
+              <a:buNone/>
+            </a:pPr>
+            <a:r>
+              <a:rPr lang="en-US" sz="1000" dirty="0">
+                <a:solidFill>
+                  <a:srgbClr val="FFFFFF"/>
+                </a:solidFill>
+                <a:latin typeface="Calibri" pitchFamily="34" charset="0"/>
+                <a:ea typeface="Calibri" pitchFamily="34" charset="-122"/>
+                <a:cs typeface="Calibri" pitchFamily="34" charset="-120"/>
+              </a:rPr>
+              <a:t>420</a:t>
+            </a:r>
+            <a:endParaRPr lang="en-US" sz="1000" dirty="0"/>
+          </a:p>
+        </p:txBody>
+      </p:sp>
+      <p:sp>
+        <p:nvSpPr>
+          <p:cNvPr id="29" name="Shape 27"/>
+          <p:cNvSpPr/>
+          <p:nvPr/>
+        </p:nvSpPr>
+        <p:spPr>
+          <a:xfrm>
+            <a:off x="320040" y="4334256"/>
+            <a:ext cx="7132320" cy="402336"/>
+          </a:xfrm>
+          <a:prstGeom prst="rect">
+            <a:avLst/>
+          </a:prstGeom>
+          <a:solidFill>
+            <a:srgbClr val="1A1A2E"/>
+          </a:solidFill>
+          <a:ln/>
+        </p:spPr>
+      </p:sp>
+      <p:sp>
+        <p:nvSpPr>
+          <p:cNvPr id="30" name="Text 28"/>
+          <p:cNvSpPr/>
+          <p:nvPr/>
+        </p:nvSpPr>
+        <p:spPr>
+          <a:xfrm>
+            <a:off x="411480" y="4334256"/>
+            <a:ext cx="3291840" cy="402336"/>
+          </a:xfrm>
+          <a:prstGeom prst="rect">
+            <a:avLst/>
+          </a:prstGeom>
+          <a:noFill/>
+          <a:ln/>
+        </p:spPr>
+        <p:txBody>
+          <a:bodyPr wrap="square" rtlCol="0" anchor="ctr"/>
+          <a:lstStyle/>
+          <a:p>
+            <a:pPr algn="l" indent="0" marL="0">
+              <a:buNone/>
+            </a:pPr>
+            <a:r>
+              <a:rPr lang="en-US" sz="1000" dirty="0">
+                <a:solidFill>
+                  <a:srgbClr val="FFFFFF"/>
+                </a:solidFill>
+                <a:latin typeface="Calibri" pitchFamily="34" charset="0"/>
+                <a:ea typeface="Calibri" pitchFamily="34" charset="-122"/>
+                <a:cs typeface="Calibri" pitchFamily="34" charset="-120"/>
+              </a:rPr>
+              <a:t>User Query (avg)</a:t>
+            </a:r>
+            <a:endParaRPr lang="en-US" sz="1000" dirty="0"/>
+          </a:p>
+        </p:txBody>
+      </p:sp>
+      <p:sp>
+        <p:nvSpPr>
+          <p:cNvPr id="31" name="Text 29"/>
+          <p:cNvSpPr/>
+          <p:nvPr/>
+        </p:nvSpPr>
+        <p:spPr>
+          <a:xfrm>
+            <a:off x="3703320" y="4334256"/>
+            <a:ext cx="1371600" cy="402336"/>
+          </a:xfrm>
+          <a:prstGeom prst="rect">
+            <a:avLst/>
+          </a:prstGeom>
+          <a:noFill/>
+          <a:ln/>
+        </p:spPr>
+        <p:txBody>
+          <a:bodyPr wrap="square" rtlCol="0" anchor="ctr"/>
+          <a:lstStyle/>
+          <a:p>
+            <a:pPr algn="ctr" indent="0" marL="0">
+              <a:buNone/>
+            </a:pPr>
+            <a:r>
+              <a:rPr lang="en-US" sz="1000" dirty="0">
+                <a:solidFill>
+                  <a:srgbClr val="FFFFFF"/>
+                </a:solidFill>
+                <a:latin typeface="Calibri" pitchFamily="34" charset="0"/>
+                <a:ea typeface="Calibri" pitchFamily="34" charset="-122"/>
+                <a:cs typeface="Calibri" pitchFamily="34" charset="-120"/>
+              </a:rPr>
+              <a:t>85</a:t>
+            </a:r>
+            <a:endParaRPr lang="en-US" sz="1000" dirty="0"/>
+          </a:p>
+        </p:txBody>
+      </p:sp>
+      <p:sp>
+        <p:nvSpPr>
+          <p:cNvPr id="32" name="Text 30"/>
+          <p:cNvSpPr/>
+          <p:nvPr/>
+        </p:nvSpPr>
+        <p:spPr>
+          <a:xfrm>
+            <a:off x="5074920" y="4334256"/>
+            <a:ext cx="1371600" cy="402336"/>
+          </a:xfrm>
+          <a:prstGeom prst="rect">
+            <a:avLst/>
+          </a:prstGeom>
+          <a:noFill/>
+          <a:ln/>
+        </p:spPr>
+        <p:txBody>
+          <a:bodyPr wrap="square" rtlCol="0" anchor="ctr"/>
+          <a:lstStyle/>
+          <a:p>
+            <a:pPr algn="ctr" indent="0" marL="0">
+              <a:buNone/>
+            </a:pPr>
+            <a:r>
+              <a:rPr lang="en-US" sz="1000" dirty="0">
+                <a:solidFill>
+                  <a:srgbClr val="FFFFFF"/>
+                </a:solidFill>
+                <a:latin typeface="Calibri" pitchFamily="34" charset="0"/>
+                <a:ea typeface="Calibri" pitchFamily="34" charset="-122"/>
+                <a:cs typeface="Calibri" pitchFamily="34" charset="-120"/>
+              </a:rPr>
+              <a:t>—</a:t>
+            </a:r>
+            <a:endParaRPr lang="en-US" sz="1000" dirty="0"/>
+          </a:p>
+        </p:txBody>
+      </p:sp>
+      <p:sp>
+        <p:nvSpPr>
+          <p:cNvPr id="33" name="Text 31"/>
+          <p:cNvSpPr/>
+          <p:nvPr/>
+        </p:nvSpPr>
+        <p:spPr>
+          <a:xfrm>
+            <a:off x="6446520" y="4334256"/>
+            <a:ext cx="1097280" cy="402336"/>
+          </a:xfrm>
+          <a:prstGeom prst="rect">
+            <a:avLst/>
+          </a:prstGeom>
+          <a:noFill/>
+          <a:ln/>
+        </p:spPr>
+        <p:txBody>
+          <a:bodyPr wrap="square" rtlCol="0" anchor="ctr"/>
+          <a:lstStyle/>
+          <a:p>
+            <a:pPr algn="ctr" indent="0" marL="0">
+              <a:buNone/>
+            </a:pPr>
+            <a:r>
+              <a:rPr lang="en-US" sz="1000" dirty="0">
+                <a:solidFill>
+                  <a:srgbClr val="FFFFFF"/>
+                </a:solidFill>
+                <a:latin typeface="Calibri" pitchFamily="34" charset="0"/>
+                <a:ea typeface="Calibri" pitchFamily="34" charset="-122"/>
+                <a:cs typeface="Calibri" pitchFamily="34" charset="-120"/>
+              </a:rPr>
+              <a:t>85</a:t>
+            </a:r>
+            <a:endParaRPr lang="en-US" sz="1000" dirty="0"/>
+          </a:p>
+        </p:txBody>
+      </p:sp>
+      <p:sp>
+        <p:nvSpPr>
+          <p:cNvPr id="34" name="Shape 32"/>
+          <p:cNvSpPr/>
+          <p:nvPr/>
+        </p:nvSpPr>
+        <p:spPr>
+          <a:xfrm>
+            <a:off x="320040" y="4754880"/>
+            <a:ext cx="7132320" cy="402336"/>
+          </a:xfrm>
+          <a:prstGeom prst="rect">
+            <a:avLst/>
+          </a:prstGeom>
+          <a:solidFill>
+            <a:srgbClr val="111122"/>
+          </a:solidFill>
+          <a:ln/>
+        </p:spPr>
+      </p:sp>
+      <p:sp>
+        <p:nvSpPr>
+          <p:cNvPr id="35" name="Text 33"/>
+          <p:cNvSpPr/>
+          <p:nvPr/>
+        </p:nvSpPr>
+        <p:spPr>
+          <a:xfrm>
+            <a:off x="411480" y="4754880"/>
+            <a:ext cx="3291840" cy="402336"/>
+          </a:xfrm>
+          <a:prstGeom prst="rect">
+            <a:avLst/>
+          </a:prstGeom>
+          <a:noFill/>
+          <a:ln/>
+        </p:spPr>
+        <p:txBody>
+          <a:bodyPr wrap="square" rtlCol="0" anchor="ctr"/>
+          <a:lstStyle/>
+          <a:p>
+            <a:pPr algn="l" indent="0" marL="0">
+              <a:buNone/>
+            </a:pPr>
+            <a:r>
+              <a:rPr lang="en-US" sz="1000" dirty="0">
+                <a:solidFill>
+                  <a:srgbClr val="FFFFFF"/>
+                </a:solidFill>
+                <a:latin typeface="Calibri" pitchFamily="34" charset="0"/>
+                <a:ea typeface="Calibri" pitchFamily="34" charset="-122"/>
+                <a:cs typeface="Calibri" pitchFamily="34" charset="-120"/>
+              </a:rPr>
+              <a:t>RAG Context (Knowledge Base)</a:t>
+            </a:r>
+            <a:endParaRPr lang="en-US" sz="1000" dirty="0"/>
+          </a:p>
+        </p:txBody>
+      </p:sp>
+      <p:sp>
+        <p:nvSpPr>
+          <p:cNvPr id="36" name="Text 34"/>
+          <p:cNvSpPr/>
+          <p:nvPr/>
+        </p:nvSpPr>
+        <p:spPr>
+          <a:xfrm>
+            <a:off x="3703320" y="4754880"/>
+            <a:ext cx="1371600" cy="402336"/>
+          </a:xfrm>
+          <a:prstGeom prst="rect">
+            <a:avLst/>
+          </a:prstGeom>
+          <a:noFill/>
+          <a:ln/>
+        </p:spPr>
+        <p:txBody>
+          <a:bodyPr wrap="square" rtlCol="0" anchor="ctr"/>
+          <a:lstStyle/>
+          <a:p>
+            <a:pPr algn="ctr" indent="0" marL="0">
+              <a:buNone/>
+            </a:pPr>
+            <a:r>
+              <a:rPr lang="en-US" sz="1000" dirty="0">
+                <a:solidFill>
+                  <a:srgbClr val="FFFFFF"/>
+                </a:solidFill>
+                <a:latin typeface="Calibri" pitchFamily="34" charset="0"/>
+                <a:ea typeface="Calibri" pitchFamily="34" charset="-122"/>
+                <a:cs typeface="Calibri" pitchFamily="34" charset="-120"/>
+              </a:rPr>
+              <a:t>1,200</a:t>
+            </a:r>
+            <a:endParaRPr lang="en-US" sz="1000" dirty="0"/>
+          </a:p>
+        </p:txBody>
+      </p:sp>
+      <p:sp>
+        <p:nvSpPr>
+          <p:cNvPr id="37" name="Text 35"/>
+          <p:cNvSpPr/>
+          <p:nvPr/>
+        </p:nvSpPr>
+        <p:spPr>
+          <a:xfrm>
+            <a:off x="5074920" y="4754880"/>
+            <a:ext cx="1371600" cy="402336"/>
+          </a:xfrm>
+          <a:prstGeom prst="rect">
+            <a:avLst/>
+          </a:prstGeom>
+          <a:noFill/>
+          <a:ln/>
+        </p:spPr>
+        <p:txBody>
+          <a:bodyPr wrap="square" rtlCol="0" anchor="ctr"/>
+          <a:lstStyle/>
+          <a:p>
+            <a:pPr algn="ctr" indent="0" marL="0">
+              <a:buNone/>
+            </a:pPr>
+            <a:r>
+              <a:rPr lang="en-US" sz="1000" dirty="0">
+                <a:solidFill>
+                  <a:srgbClr val="FFFFFF"/>
+                </a:solidFill>
+                <a:latin typeface="Calibri" pitchFamily="34" charset="0"/>
+                <a:ea typeface="Calibri" pitchFamily="34" charset="-122"/>
+                <a:cs typeface="Calibri" pitchFamily="34" charset="-120"/>
+              </a:rPr>
+              <a:t>—</a:t>
+            </a:r>
+            <a:endParaRPr lang="en-US" sz="1000" dirty="0"/>
+          </a:p>
+        </p:txBody>
+      </p:sp>
+      <p:sp>
+        <p:nvSpPr>
+          <p:cNvPr id="38" name="Text 36"/>
+          <p:cNvSpPr/>
+          <p:nvPr/>
+        </p:nvSpPr>
+        <p:spPr>
+          <a:xfrm>
+            <a:off x="6446520" y="4754880"/>
+            <a:ext cx="1097280" cy="402336"/>
+          </a:xfrm>
+          <a:prstGeom prst="rect">
+            <a:avLst/>
+          </a:prstGeom>
+          <a:noFill/>
+          <a:ln/>
+        </p:spPr>
+        <p:txBody>
+          <a:bodyPr wrap="square" rtlCol="0" anchor="ctr"/>
+          <a:lstStyle/>
+          <a:p>
+            <a:pPr algn="ctr" indent="0" marL="0">
+              <a:buNone/>
+            </a:pPr>
+            <a:r>
+              <a:rPr lang="en-US" sz="1000" dirty="0">
+                <a:solidFill>
+                  <a:srgbClr val="FFFFFF"/>
+                </a:solidFill>
+                <a:latin typeface="Calibri" pitchFamily="34" charset="0"/>
+                <a:ea typeface="Calibri" pitchFamily="34" charset="-122"/>
+                <a:cs typeface="Calibri" pitchFamily="34" charset="-120"/>
+              </a:rPr>
+              <a:t>1,200</a:t>
+            </a:r>
+            <a:endParaRPr lang="en-US" sz="1000" dirty="0"/>
+          </a:p>
+        </p:txBody>
+      </p:sp>
+      <p:sp>
+        <p:nvSpPr>
+          <p:cNvPr id="39" name="Shape 37"/>
+          <p:cNvSpPr/>
+          <p:nvPr/>
+        </p:nvSpPr>
+        <p:spPr>
+          <a:xfrm>
+            <a:off x="320040" y="5175504"/>
+            <a:ext cx="7132320" cy="402336"/>
+          </a:xfrm>
+          <a:prstGeom prst="rect">
+            <a:avLst/>
+          </a:prstGeom>
+          <a:solidFill>
+            <a:srgbClr val="1A1A2E"/>
+          </a:solidFill>
+          <a:ln/>
+        </p:spPr>
+      </p:sp>
+      <p:sp>
+        <p:nvSpPr>
+          <p:cNvPr id="40" name="Text 38"/>
+          <p:cNvSpPr/>
+          <p:nvPr/>
+        </p:nvSpPr>
+        <p:spPr>
+          <a:xfrm>
+            <a:off x="411480" y="5175504"/>
+            <a:ext cx="3291840" cy="402336"/>
+          </a:xfrm>
+          <a:prstGeom prst="rect">
+            <a:avLst/>
+          </a:prstGeom>
+          <a:noFill/>
+          <a:ln/>
+        </p:spPr>
+        <p:txBody>
+          <a:bodyPr wrap="square" rtlCol="0" anchor="ctr"/>
+          <a:lstStyle/>
+          <a:p>
+            <a:pPr algn="l" indent="0" marL="0">
+              <a:buNone/>
+            </a:pPr>
+            <a:r>
+              <a:rPr lang="en-US" sz="1000" dirty="0">
+                <a:solidFill>
+                  <a:srgbClr val="FFFFFF"/>
+                </a:solidFill>
+                <a:latin typeface="Calibri" pitchFamily="34" charset="0"/>
+                <a:ea typeface="Calibri" pitchFamily="34" charset="-122"/>
+                <a:cs typeface="Calibri" pitchFamily="34" charset="-120"/>
+              </a:rPr>
+              <a:t>Family Profile Input</a:t>
+            </a:r>
+            <a:endParaRPr lang="en-US" sz="1000" dirty="0"/>
+          </a:p>
+        </p:txBody>
+      </p:sp>
+      <p:sp>
+        <p:nvSpPr>
+          <p:cNvPr id="41" name="Text 39"/>
+          <p:cNvSpPr/>
+          <p:nvPr/>
+        </p:nvSpPr>
+        <p:spPr>
+          <a:xfrm>
+            <a:off x="3703320" y="5175504"/>
+            <a:ext cx="1371600" cy="402336"/>
+          </a:xfrm>
+          <a:prstGeom prst="rect">
+            <a:avLst/>
+          </a:prstGeom>
+          <a:noFill/>
+          <a:ln/>
+        </p:spPr>
+        <p:txBody>
+          <a:bodyPr wrap="square" rtlCol="0" anchor="ctr"/>
+          <a:lstStyle/>
+          <a:p>
+            <a:pPr algn="ctr" indent="0" marL="0">
+              <a:buNone/>
+            </a:pPr>
+            <a:r>
+              <a:rPr lang="en-US" sz="1000" dirty="0">
+                <a:solidFill>
+                  <a:srgbClr val="FFFFFF"/>
+                </a:solidFill>
+                <a:latin typeface="Calibri" pitchFamily="34" charset="0"/>
+                <a:ea typeface="Calibri" pitchFamily="34" charset="-122"/>
+                <a:cs typeface="Calibri" pitchFamily="34" charset="-120"/>
+              </a:rPr>
+              <a:t>180</a:t>
+            </a:r>
+            <a:endParaRPr lang="en-US" sz="1000" dirty="0"/>
+          </a:p>
+        </p:txBody>
+      </p:sp>
+      <p:sp>
+        <p:nvSpPr>
+          <p:cNvPr id="42" name="Text 40"/>
+          <p:cNvSpPr/>
+          <p:nvPr/>
+        </p:nvSpPr>
+        <p:spPr>
+          <a:xfrm>
+            <a:off x="5074920" y="5175504"/>
+            <a:ext cx="1371600" cy="402336"/>
+          </a:xfrm>
+          <a:prstGeom prst="rect">
+            <a:avLst/>
+          </a:prstGeom>
+          <a:noFill/>
+          <a:ln/>
+        </p:spPr>
+        <p:txBody>
+          <a:bodyPr wrap="square" rtlCol="0" anchor="ctr"/>
+          <a:lstStyle/>
+          <a:p>
+            <a:pPr algn="ctr" indent="0" marL="0">
+              <a:buNone/>
+            </a:pPr>
+            <a:r>
+              <a:rPr lang="en-US" sz="1000" dirty="0">
+                <a:solidFill>
+                  <a:srgbClr val="FFFFFF"/>
+                </a:solidFill>
+                <a:latin typeface="Calibri" pitchFamily="34" charset="0"/>
+                <a:ea typeface="Calibri" pitchFamily="34" charset="-122"/>
+                <a:cs typeface="Calibri" pitchFamily="34" charset="-120"/>
+              </a:rPr>
+              <a:t>—</a:t>
+            </a:r>
+            <a:endParaRPr lang="en-US" sz="1000" dirty="0"/>
+          </a:p>
+        </p:txBody>
+      </p:sp>
+      <p:sp>
+        <p:nvSpPr>
+          <p:cNvPr id="43" name="Text 41"/>
+          <p:cNvSpPr/>
+          <p:nvPr/>
+        </p:nvSpPr>
+        <p:spPr>
+          <a:xfrm>
+            <a:off x="6446520" y="5175504"/>
+            <a:ext cx="1097280" cy="402336"/>
+          </a:xfrm>
+          <a:prstGeom prst="rect">
+            <a:avLst/>
+          </a:prstGeom>
+          <a:noFill/>
+          <a:ln/>
+        </p:spPr>
+        <p:txBody>
+          <a:bodyPr wrap="square" rtlCol="0" anchor="ctr"/>
+          <a:lstStyle/>
+          <a:p>
+            <a:pPr algn="ctr" indent="0" marL="0">
+              <a:buNone/>
+            </a:pPr>
+            <a:r>
+              <a:rPr lang="en-US" sz="1000" dirty="0">
+                <a:solidFill>
+                  <a:srgbClr val="FFFFFF"/>
+                </a:solidFill>
+                <a:latin typeface="Calibri" pitchFamily="34" charset="0"/>
+                <a:ea typeface="Calibri" pitchFamily="34" charset="-122"/>
+                <a:cs typeface="Calibri" pitchFamily="34" charset="-120"/>
+              </a:rPr>
+              <a:t>180</a:t>
+            </a:r>
+            <a:endParaRPr lang="en-US" sz="1000" dirty="0"/>
+          </a:p>
+        </p:txBody>
+      </p:sp>
+      <p:sp>
+        <p:nvSpPr>
+          <p:cNvPr id="44" name="Shape 42"/>
+          <p:cNvSpPr/>
+          <p:nvPr/>
+        </p:nvSpPr>
+        <p:spPr>
+          <a:xfrm>
+            <a:off x="320040" y="5596128"/>
+            <a:ext cx="7132320" cy="402336"/>
+          </a:xfrm>
+          <a:prstGeom prst="rect">
+            <a:avLst/>
+          </a:prstGeom>
+          <a:solidFill>
+            <a:srgbClr val="111122"/>
+          </a:solidFill>
+          <a:ln/>
+        </p:spPr>
+      </p:sp>
+      <p:sp>
+        <p:nvSpPr>
+          <p:cNvPr id="45" name="Text 43"/>
+          <p:cNvSpPr/>
+          <p:nvPr/>
+        </p:nvSpPr>
+        <p:spPr>
+          <a:xfrm>
+            <a:off x="411480" y="5596128"/>
+            <a:ext cx="3291840" cy="402336"/>
+          </a:xfrm>
+          <a:prstGeom prst="rect">
+            <a:avLst/>
+          </a:prstGeom>
+          <a:noFill/>
+          <a:ln/>
+        </p:spPr>
+        <p:txBody>
+          <a:bodyPr wrap="square" rtlCol="0" anchor="ctr"/>
+          <a:lstStyle/>
+          <a:p>
+            <a:pPr algn="l" indent="0" marL="0">
+              <a:buNone/>
+            </a:pPr>
+            <a:r>
+              <a:rPr lang="en-US" sz="1000" dirty="0">
+                <a:solidFill>
+                  <a:srgbClr val="FFFFFF"/>
+                </a:solidFill>
+                <a:latin typeface="Calibri" pitchFamily="34" charset="0"/>
+                <a:ea typeface="Calibri" pitchFamily="34" charset="-122"/>
+                <a:cs typeface="Calibri" pitchFamily="34" charset="-120"/>
+              </a:rPr>
+              <a:t>Granite Model Response</a:t>
+            </a:r>
+            <a:endParaRPr lang="en-US" sz="1000" dirty="0"/>
+          </a:p>
+        </p:txBody>
+      </p:sp>
+      <p:sp>
+        <p:nvSpPr>
+          <p:cNvPr id="46" name="Text 44"/>
+          <p:cNvSpPr/>
+          <p:nvPr/>
+        </p:nvSpPr>
+        <p:spPr>
+          <a:xfrm>
+            <a:off x="3703320" y="5596128"/>
+            <a:ext cx="1371600" cy="402336"/>
+          </a:xfrm>
+          <a:prstGeom prst="rect">
+            <a:avLst/>
+          </a:prstGeom>
+          <a:noFill/>
+          <a:ln/>
+        </p:spPr>
+        <p:txBody>
+          <a:bodyPr wrap="square" rtlCol="0" anchor="ctr"/>
+          <a:lstStyle/>
+          <a:p>
+            <a:pPr algn="ctr" indent="0" marL="0">
+              <a:buNone/>
+            </a:pPr>
+            <a:r>
+              <a:rPr lang="en-US" sz="1000" dirty="0">
+                <a:solidFill>
+                  <a:srgbClr val="FFFFFF"/>
+                </a:solidFill>
+                <a:latin typeface="Calibri" pitchFamily="34" charset="0"/>
+                <a:ea typeface="Calibri" pitchFamily="34" charset="-122"/>
+                <a:cs typeface="Calibri" pitchFamily="34" charset="-120"/>
+              </a:rPr>
+              <a:t>—</a:t>
+            </a:r>
+            <a:endParaRPr lang="en-US" sz="1000" dirty="0"/>
+          </a:p>
+        </p:txBody>
+      </p:sp>
+      <p:sp>
+        <p:nvSpPr>
+          <p:cNvPr id="47" name="Text 45"/>
+          <p:cNvSpPr/>
+          <p:nvPr/>
+        </p:nvSpPr>
+        <p:spPr>
+          <a:xfrm>
+            <a:off x="5074920" y="5596128"/>
+            <a:ext cx="1371600" cy="402336"/>
+          </a:xfrm>
+          <a:prstGeom prst="rect">
+            <a:avLst/>
+          </a:prstGeom>
+          <a:noFill/>
+          <a:ln/>
+        </p:spPr>
+        <p:txBody>
+          <a:bodyPr wrap="square" rtlCol="0" anchor="ctr"/>
+          <a:lstStyle/>
+          <a:p>
+            <a:pPr algn="ctr" indent="0" marL="0">
+              <a:buNone/>
+            </a:pPr>
+            <a:r>
+              <a:rPr lang="en-US" sz="1000" dirty="0">
+                <a:solidFill>
+                  <a:srgbClr val="FFFFFF"/>
+                </a:solidFill>
+                <a:latin typeface="Calibri" pitchFamily="34" charset="0"/>
+                <a:ea typeface="Calibri" pitchFamily="34" charset="-122"/>
+                <a:cs typeface="Calibri" pitchFamily="34" charset="-120"/>
+              </a:rPr>
+              <a:t>876</a:t>
+            </a:r>
+            <a:endParaRPr lang="en-US" sz="1000" dirty="0"/>
+          </a:p>
+        </p:txBody>
+      </p:sp>
+      <p:sp>
+        <p:nvSpPr>
+          <p:cNvPr id="48" name="Text 46"/>
+          <p:cNvSpPr/>
+          <p:nvPr/>
+        </p:nvSpPr>
+        <p:spPr>
+          <a:xfrm>
+            <a:off x="6446520" y="5596128"/>
+            <a:ext cx="1097280" cy="402336"/>
+          </a:xfrm>
+          <a:prstGeom prst="rect">
+            <a:avLst/>
+          </a:prstGeom>
+          <a:noFill/>
+          <a:ln/>
+        </p:spPr>
+        <p:txBody>
+          <a:bodyPr wrap="square" rtlCol="0" anchor="ctr"/>
+          <a:lstStyle/>
+          <a:p>
+            <a:pPr algn="ctr" indent="0" marL="0">
+              <a:buNone/>
+            </a:pPr>
+            <a:r>
+              <a:rPr lang="en-US" sz="1000" dirty="0">
+                <a:solidFill>
+                  <a:srgbClr val="FFFFFF"/>
+                </a:solidFill>
+                <a:latin typeface="Calibri" pitchFamily="34" charset="0"/>
+                <a:ea typeface="Calibri" pitchFamily="34" charset="-122"/>
+                <a:cs typeface="Calibri" pitchFamily="34" charset="-120"/>
+              </a:rPr>
+              <a:t>876</a:t>
+            </a:r>
+            <a:endParaRPr lang="en-US" sz="1000" dirty="0"/>
+          </a:p>
+        </p:txBody>
+      </p:sp>
+      <p:sp>
+        <p:nvSpPr>
+          <p:cNvPr id="49" name="Shape 47"/>
+          <p:cNvSpPr/>
+          <p:nvPr/>
+        </p:nvSpPr>
+        <p:spPr>
+          <a:xfrm>
+            <a:off x="320040" y="6016752"/>
+            <a:ext cx="7132320" cy="402336"/>
+          </a:xfrm>
+          <a:prstGeom prst="rect">
+            <a:avLst/>
+          </a:prstGeom>
+          <a:solidFill>
+            <a:srgbClr val="08A836"/>
+          </a:solidFill>
+          <a:ln/>
+        </p:spPr>
+      </p:sp>
+      <p:sp>
+        <p:nvSpPr>
+          <p:cNvPr id="50" name="Text 48"/>
+          <p:cNvSpPr/>
+          <p:nvPr/>
+        </p:nvSpPr>
+        <p:spPr>
+          <a:xfrm>
+            <a:off x="411480" y="6016752"/>
+            <a:ext cx="3291840" cy="402336"/>
+          </a:xfrm>
+          <a:prstGeom prst="rect">
+            <a:avLst/>
+          </a:prstGeom>
+          <a:noFill/>
+          <a:ln/>
+        </p:spPr>
+        <p:txBody>
+          <a:bodyPr wrap="square" rtlCol="0" anchor="ctr"/>
+          <a:lstStyle/>
+          <a:p>
+            <a:pPr algn="l" indent="0" marL="0">
+              <a:buNone/>
+            </a:pPr>
+            <a:r>
+              <a:rPr lang="en-US" sz="1000" b="1" dirty="0">
+                <a:solidFill>
+                  <a:srgbClr val="FFFFFF"/>
+                </a:solidFill>
+                <a:latin typeface="Calibri" pitchFamily="34" charset="0"/>
+                <a:ea typeface="Calibri" pitchFamily="34" charset="-122"/>
+                <a:cs typeface="Calibri" pitchFamily="34" charset="-120"/>
+              </a:rPr>
+              <a:t>TOTAL</a:t>
+            </a:r>
+            <a:endParaRPr lang="en-US" sz="1000" dirty="0"/>
+          </a:p>
+        </p:txBody>
+      </p:sp>
+      <p:sp>
+        <p:nvSpPr>
+          <p:cNvPr id="51" name="Text 49"/>
+          <p:cNvSpPr/>
+          <p:nvPr/>
+        </p:nvSpPr>
+        <p:spPr>
+          <a:xfrm>
+            <a:off x="3703320" y="6016752"/>
+            <a:ext cx="1371600" cy="402336"/>
+          </a:xfrm>
+          <a:prstGeom prst="rect">
+            <a:avLst/>
+          </a:prstGeom>
+          <a:noFill/>
+          <a:ln/>
+        </p:spPr>
+        <p:txBody>
+          <a:bodyPr wrap="square" rtlCol="0" anchor="ctr"/>
+          <a:lstStyle/>
+          <a:p>
+            <a:pPr algn="ctr" indent="0" marL="0">
+              <a:buNone/>
+            </a:pPr>
+            <a:r>
+              <a:rPr lang="en-US" sz="1000" b="1" dirty="0">
+                <a:solidFill>
+                  <a:srgbClr val="FFFFFF"/>
+                </a:solidFill>
+                <a:latin typeface="Calibri" pitchFamily="34" charset="0"/>
+                <a:ea typeface="Calibri" pitchFamily="34" charset="-122"/>
+                <a:cs typeface="Calibri" pitchFamily="34" charset="-120"/>
+              </a:rPr>
+              <a:t>1,885</a:t>
+            </a:r>
+            <a:endParaRPr lang="en-US" sz="1000" dirty="0"/>
+          </a:p>
+        </p:txBody>
+      </p:sp>
+      <p:sp>
+        <p:nvSpPr>
+          <p:cNvPr id="52" name="Text 50"/>
+          <p:cNvSpPr/>
+          <p:nvPr/>
+        </p:nvSpPr>
+        <p:spPr>
+          <a:xfrm>
+            <a:off x="5074920" y="6016752"/>
+            <a:ext cx="1371600" cy="402336"/>
+          </a:xfrm>
+          <a:prstGeom prst="rect">
+            <a:avLst/>
+          </a:prstGeom>
+          <a:noFill/>
+          <a:ln/>
+        </p:spPr>
+        <p:txBody>
+          <a:bodyPr wrap="square" rtlCol="0" anchor="ctr"/>
+          <a:lstStyle/>
+          <a:p>
+            <a:pPr algn="ctr" indent="0" marL="0">
+              <a:buNone/>
+            </a:pPr>
+            <a:r>
+              <a:rPr lang="en-US" sz="1000" b="1" dirty="0">
+                <a:solidFill>
+                  <a:srgbClr val="FFFFFF"/>
+                </a:solidFill>
+                <a:latin typeface="Calibri" pitchFamily="34" charset="0"/>
+                <a:ea typeface="Calibri" pitchFamily="34" charset="-122"/>
+                <a:cs typeface="Calibri" pitchFamily="34" charset="-120"/>
+              </a:rPr>
+              <a:t>876</a:t>
+            </a:r>
+            <a:endParaRPr lang="en-US" sz="1000" dirty="0"/>
+          </a:p>
+        </p:txBody>
+      </p:sp>
+      <p:sp>
+        <p:nvSpPr>
+          <p:cNvPr id="53" name="Text 51"/>
+          <p:cNvSpPr/>
+          <p:nvPr/>
+        </p:nvSpPr>
+        <p:spPr>
+          <a:xfrm>
+            <a:off x="6446520" y="6016752"/>
+            <a:ext cx="1097280" cy="402336"/>
+          </a:xfrm>
+          <a:prstGeom prst="rect">
+            <a:avLst/>
+          </a:prstGeom>
+          <a:noFill/>
+          <a:ln/>
+        </p:spPr>
+        <p:txBody>
+          <a:bodyPr wrap="square" rtlCol="0" anchor="ctr"/>
+          <a:lstStyle/>
+          <a:p>
+            <a:pPr algn="ctr" indent="0" marL="0">
+              <a:buNone/>
+            </a:pPr>
+            <a:r>
+              <a:rPr lang="en-US" sz="1000" b="1" dirty="0">
+                <a:solidFill>
+                  <a:srgbClr val="FFFFFF"/>
+                </a:solidFill>
+                <a:latin typeface="Calibri" pitchFamily="34" charset="0"/>
+                <a:ea typeface="Calibri" pitchFamily="34" charset="-122"/>
+                <a:cs typeface="Calibri" pitchFamily="34" charset="-120"/>
+              </a:rPr>
+              <a:t>2,761</a:t>
+            </a:r>
+            <a:endParaRPr lang="en-US" sz="1000" dirty="0"/>
+          </a:p>
+        </p:txBody>
+      </p:sp>
+      <p:sp>
+        <p:nvSpPr>
+          <p:cNvPr id="54" name="Shape 52"/>
+          <p:cNvSpPr/>
+          <p:nvPr/>
+        </p:nvSpPr>
+        <p:spPr>
+          <a:xfrm>
+            <a:off x="7680960" y="2880360"/>
+            <a:ext cx="4206240" cy="3520440"/>
+          </a:xfrm>
+          <a:prstGeom prst="roundRect">
+            <a:avLst>
+              <a:gd name="adj" fmla="val 2597"/>
+            </a:avLst>
+          </a:prstGeom>
+          <a:solidFill>
+            <a:srgbClr val="111122"/>
+          </a:solidFill>
+          <a:ln/>
+        </p:spPr>
+      </p:sp>
+      <p:sp>
+        <p:nvSpPr>
+          <p:cNvPr id="55" name="Text 53"/>
+          <p:cNvSpPr/>
+          <p:nvPr/>
+        </p:nvSpPr>
+        <p:spPr>
+          <a:xfrm>
+            <a:off x="7863840" y="3017520"/>
+            <a:ext cx="3840480" cy="384048"/>
           </a:xfrm>
           <a:prstGeom prst="rect">
             <a:avLst/>
@@ -3220,15 +4561,839 @@
               <a:buNone/>
             </a:pPr>
             <a:r>
+              <a:rPr lang="en-US" sz="1200" b="1" dirty="0">
+                <a:solidFill>
+                  <a:srgbClr val="FFFFFF"/>
+                </a:solidFill>
+                <a:latin typeface="Calibri" pitchFamily="34" charset="0"/>
+                <a:ea typeface="Calibri" pitchFamily="34" charset="-122"/>
+                <a:cs typeface="Calibri" pitchFamily="34" charset="-120"/>
+              </a:rPr>
+              <a:t>Model Configuration</a:t>
+            </a:r>
+            <a:endParaRPr lang="en-US" sz="1200" dirty="0"/>
+          </a:p>
+        </p:txBody>
+      </p:sp>
+      <p:sp>
+        <p:nvSpPr>
+          <p:cNvPr id="56" name="Text 54"/>
+          <p:cNvSpPr/>
+          <p:nvPr/>
+        </p:nvSpPr>
+        <p:spPr>
+          <a:xfrm>
+            <a:off x="7818120" y="3547872"/>
+            <a:ext cx="1828800" cy="347472"/>
+          </a:xfrm>
+          <a:prstGeom prst="rect">
+            <a:avLst/>
+          </a:prstGeom>
+          <a:noFill/>
+          <a:ln/>
+        </p:spPr>
+        <p:txBody>
+          <a:bodyPr wrap="square" rtlCol="0" anchor="ctr"/>
+          <a:lstStyle/>
+          <a:p>
+            <a:pPr indent="0" marL="0">
+              <a:buNone/>
+            </a:pPr>
+            <a:r>
+              <a:rPr lang="en-US" sz="950" dirty="0">
+                <a:solidFill>
+                  <a:srgbClr val="8899CC"/>
+                </a:solidFill>
+                <a:latin typeface="Calibri" pitchFamily="34" charset="0"/>
+                <a:ea typeface="Calibri" pitchFamily="34" charset="-122"/>
+                <a:cs typeface="Calibri" pitchFamily="34" charset="-120"/>
+              </a:rPr>
+              <a:t>Model</a:t>
+            </a:r>
+            <a:endParaRPr lang="en-US" sz="950" dirty="0"/>
+          </a:p>
+        </p:txBody>
+      </p:sp>
+      <p:sp>
+        <p:nvSpPr>
+          <p:cNvPr id="57" name="Text 55"/>
+          <p:cNvSpPr/>
+          <p:nvPr/>
+        </p:nvSpPr>
+        <p:spPr>
+          <a:xfrm>
+            <a:off x="9692640" y="3547872"/>
+            <a:ext cx="2011680" cy="347472"/>
+          </a:xfrm>
+          <a:prstGeom prst="rect">
+            <a:avLst/>
+          </a:prstGeom>
+          <a:noFill/>
+          <a:ln/>
+        </p:spPr>
+        <p:txBody>
+          <a:bodyPr wrap="square" rtlCol="0" anchor="ctr"/>
+          <a:lstStyle/>
+          <a:p>
+            <a:pPr indent="0" marL="0">
+              <a:buNone/>
+            </a:pPr>
+            <a:r>
+              <a:rPr lang="en-US" sz="950" b="1" dirty="0">
+                <a:solidFill>
+                  <a:srgbClr val="FFFFFF"/>
+                </a:solidFill>
+                <a:latin typeface="Calibri" pitchFamily="34" charset="0"/>
+                <a:ea typeface="Calibri" pitchFamily="34" charset="-122"/>
+                <a:cs typeface="Calibri" pitchFamily="34" charset="-120"/>
+              </a:rPr>
+              <a:t>ibm/granite-3-2-8b-instruct</a:t>
+            </a:r>
+            <a:endParaRPr lang="en-US" sz="950" dirty="0"/>
+          </a:p>
+        </p:txBody>
+      </p:sp>
+      <p:sp>
+        <p:nvSpPr>
+          <p:cNvPr id="58" name="Shape 56"/>
+          <p:cNvSpPr/>
+          <p:nvPr/>
+        </p:nvSpPr>
+        <p:spPr>
+          <a:xfrm>
+            <a:off x="7818120" y="3895344"/>
+            <a:ext cx="3840480" cy="0"/>
+          </a:xfrm>
+          <a:prstGeom prst="line">
+            <a:avLst/>
+          </a:prstGeom>
+          <a:noFill/>
+          <a:ln w="6350">
+            <a:solidFill>
+              <a:srgbClr val="222233"/>
+            </a:solidFill>
+            <a:prstDash val="solid"/>
+          </a:ln>
+        </p:spPr>
+      </p:sp>
+      <p:sp>
+        <p:nvSpPr>
+          <p:cNvPr id="59" name="Text 57"/>
+          <p:cNvSpPr/>
+          <p:nvPr/>
+        </p:nvSpPr>
+        <p:spPr>
+          <a:xfrm>
+            <a:off x="7818120" y="3931920"/>
+            <a:ext cx="1828800" cy="347472"/>
+          </a:xfrm>
+          <a:prstGeom prst="rect">
+            <a:avLst/>
+          </a:prstGeom>
+          <a:noFill/>
+          <a:ln/>
+        </p:spPr>
+        <p:txBody>
+          <a:bodyPr wrap="square" rtlCol="0" anchor="ctr"/>
+          <a:lstStyle/>
+          <a:p>
+            <a:pPr indent="0" marL="0">
+              <a:buNone/>
+            </a:pPr>
+            <a:r>
+              <a:rPr lang="en-US" sz="950" dirty="0">
+                <a:solidFill>
+                  <a:srgbClr val="8899CC"/>
+                </a:solidFill>
+                <a:latin typeface="Calibri" pitchFamily="34" charset="0"/>
+                <a:ea typeface="Calibri" pitchFamily="34" charset="-122"/>
+                <a:cs typeface="Calibri" pitchFamily="34" charset="-120"/>
+              </a:rPr>
+              <a:t>Platform</a:t>
+            </a:r>
+            <a:endParaRPr lang="en-US" sz="950" dirty="0"/>
+          </a:p>
+        </p:txBody>
+      </p:sp>
+      <p:sp>
+        <p:nvSpPr>
+          <p:cNvPr id="60" name="Text 58"/>
+          <p:cNvSpPr/>
+          <p:nvPr/>
+        </p:nvSpPr>
+        <p:spPr>
+          <a:xfrm>
+            <a:off x="9692640" y="3931920"/>
+            <a:ext cx="2011680" cy="347472"/>
+          </a:xfrm>
+          <a:prstGeom prst="rect">
+            <a:avLst/>
+          </a:prstGeom>
+          <a:noFill/>
+          <a:ln/>
+        </p:spPr>
+        <p:txBody>
+          <a:bodyPr wrap="square" rtlCol="0" anchor="ctr"/>
+          <a:lstStyle/>
+          <a:p>
+            <a:pPr indent="0" marL="0">
+              <a:buNone/>
+            </a:pPr>
+            <a:r>
+              <a:rPr lang="en-US" sz="950" b="1" dirty="0">
+                <a:solidFill>
+                  <a:srgbClr val="FFFFFF"/>
+                </a:solidFill>
+                <a:latin typeface="Calibri" pitchFamily="34" charset="0"/>
+                <a:ea typeface="Calibri" pitchFamily="34" charset="-122"/>
+                <a:cs typeface="Calibri" pitchFamily="34" charset="-120"/>
+              </a:rPr>
+              <a:t>IBM watsonx.ai</a:t>
+            </a:r>
+            <a:endParaRPr lang="en-US" sz="950" dirty="0"/>
+          </a:p>
+        </p:txBody>
+      </p:sp>
+      <p:sp>
+        <p:nvSpPr>
+          <p:cNvPr id="61" name="Shape 59"/>
+          <p:cNvSpPr/>
+          <p:nvPr/>
+        </p:nvSpPr>
+        <p:spPr>
+          <a:xfrm>
+            <a:off x="7818120" y="4279392"/>
+            <a:ext cx="3840480" cy="0"/>
+          </a:xfrm>
+          <a:prstGeom prst="line">
+            <a:avLst/>
+          </a:prstGeom>
+          <a:noFill/>
+          <a:ln w="6350">
+            <a:solidFill>
+              <a:srgbClr val="222233"/>
+            </a:solidFill>
+            <a:prstDash val="solid"/>
+          </a:ln>
+        </p:spPr>
+      </p:sp>
+      <p:sp>
+        <p:nvSpPr>
+          <p:cNvPr id="62" name="Text 60"/>
+          <p:cNvSpPr/>
+          <p:nvPr/>
+        </p:nvSpPr>
+        <p:spPr>
+          <a:xfrm>
+            <a:off x="7818120" y="4315968"/>
+            <a:ext cx="1828800" cy="347472"/>
+          </a:xfrm>
+          <a:prstGeom prst="rect">
+            <a:avLst/>
+          </a:prstGeom>
+          <a:noFill/>
+          <a:ln/>
+        </p:spPr>
+        <p:txBody>
+          <a:bodyPr wrap="square" rtlCol="0" anchor="ctr"/>
+          <a:lstStyle/>
+          <a:p>
+            <a:pPr indent="0" marL="0">
+              <a:buNone/>
+            </a:pPr>
+            <a:r>
+              <a:rPr lang="en-US" sz="950" dirty="0">
+                <a:solidFill>
+                  <a:srgbClr val="8899CC"/>
+                </a:solidFill>
+                <a:latin typeface="Calibri" pitchFamily="34" charset="0"/>
+                <a:ea typeface="Calibri" pitchFamily="34" charset="-122"/>
+                <a:cs typeface="Calibri" pitchFamily="34" charset="-120"/>
+              </a:rPr>
+              <a:t>Region</a:t>
+            </a:r>
+            <a:endParaRPr lang="en-US" sz="950" dirty="0"/>
+          </a:p>
+        </p:txBody>
+      </p:sp>
+      <p:sp>
+        <p:nvSpPr>
+          <p:cNvPr id="63" name="Text 61"/>
+          <p:cNvSpPr/>
+          <p:nvPr/>
+        </p:nvSpPr>
+        <p:spPr>
+          <a:xfrm>
+            <a:off x="9692640" y="4315968"/>
+            <a:ext cx="2011680" cy="347472"/>
+          </a:xfrm>
+          <a:prstGeom prst="rect">
+            <a:avLst/>
+          </a:prstGeom>
+          <a:noFill/>
+          <a:ln/>
+        </p:spPr>
+        <p:txBody>
+          <a:bodyPr wrap="square" rtlCol="0" anchor="ctr"/>
+          <a:lstStyle/>
+          <a:p>
+            <a:pPr indent="0" marL="0">
+              <a:buNone/>
+            </a:pPr>
+            <a:r>
+              <a:rPr lang="en-US" sz="950" b="1" dirty="0">
+                <a:solidFill>
+                  <a:srgbClr val="FFFFFF"/>
+                </a:solidFill>
+                <a:latin typeface="Calibri" pitchFamily="34" charset="0"/>
+                <a:ea typeface="Calibri" pitchFamily="34" charset="-122"/>
+                <a:cs typeface="Calibri" pitchFamily="34" charset="-120"/>
+              </a:rPr>
+              <a:t>us-south</a:t>
+            </a:r>
+            <a:endParaRPr lang="en-US" sz="950" dirty="0"/>
+          </a:p>
+        </p:txBody>
+      </p:sp>
+      <p:sp>
+        <p:nvSpPr>
+          <p:cNvPr id="64" name="Shape 62"/>
+          <p:cNvSpPr/>
+          <p:nvPr/>
+        </p:nvSpPr>
+        <p:spPr>
+          <a:xfrm>
+            <a:off x="7818120" y="4663440"/>
+            <a:ext cx="3840480" cy="0"/>
+          </a:xfrm>
+          <a:prstGeom prst="line">
+            <a:avLst/>
+          </a:prstGeom>
+          <a:noFill/>
+          <a:ln w="6350">
+            <a:solidFill>
+              <a:srgbClr val="222233"/>
+            </a:solidFill>
+            <a:prstDash val="solid"/>
+          </a:ln>
+        </p:spPr>
+      </p:sp>
+      <p:sp>
+        <p:nvSpPr>
+          <p:cNvPr id="65" name="Text 63"/>
+          <p:cNvSpPr/>
+          <p:nvPr/>
+        </p:nvSpPr>
+        <p:spPr>
+          <a:xfrm>
+            <a:off x="7818120" y="4700016"/>
+            <a:ext cx="1828800" cy="347472"/>
+          </a:xfrm>
+          <a:prstGeom prst="rect">
+            <a:avLst/>
+          </a:prstGeom>
+          <a:noFill/>
+          <a:ln/>
+        </p:spPr>
+        <p:txBody>
+          <a:bodyPr wrap="square" rtlCol="0" anchor="ctr"/>
+          <a:lstStyle/>
+          <a:p>
+            <a:pPr indent="0" marL="0">
+              <a:buNone/>
+            </a:pPr>
+            <a:r>
+              <a:rPr lang="en-US" sz="950" dirty="0">
+                <a:solidFill>
+                  <a:srgbClr val="8899CC"/>
+                </a:solidFill>
+                <a:latin typeface="Calibri" pitchFamily="34" charset="0"/>
+                <a:ea typeface="Calibri" pitchFamily="34" charset="-122"/>
+                <a:cs typeface="Calibri" pitchFamily="34" charset="-120"/>
+              </a:rPr>
+              <a:t>Max New Tokens</a:t>
+            </a:r>
+            <a:endParaRPr lang="en-US" sz="950" dirty="0"/>
+          </a:p>
+        </p:txBody>
+      </p:sp>
+      <p:sp>
+        <p:nvSpPr>
+          <p:cNvPr id="66" name="Text 64"/>
+          <p:cNvSpPr/>
+          <p:nvPr/>
+        </p:nvSpPr>
+        <p:spPr>
+          <a:xfrm>
+            <a:off x="9692640" y="4700016"/>
+            <a:ext cx="2011680" cy="347472"/>
+          </a:xfrm>
+          <a:prstGeom prst="rect">
+            <a:avLst/>
+          </a:prstGeom>
+          <a:noFill/>
+          <a:ln/>
+        </p:spPr>
+        <p:txBody>
+          <a:bodyPr wrap="square" rtlCol="0" anchor="ctr"/>
+          <a:lstStyle/>
+          <a:p>
+            <a:pPr indent="0" marL="0">
+              <a:buNone/>
+            </a:pPr>
+            <a:r>
+              <a:rPr lang="en-US" sz="950" b="1" dirty="0">
+                <a:solidFill>
+                  <a:srgbClr val="FFFFFF"/>
+                </a:solidFill>
+                <a:latin typeface="Calibri" pitchFamily="34" charset="0"/>
+                <a:ea typeface="Calibri" pitchFamily="34" charset="-122"/>
+                <a:cs typeface="Calibri" pitchFamily="34" charset="-120"/>
+              </a:rPr>
+              <a:t>1,024</a:t>
+            </a:r>
+            <a:endParaRPr lang="en-US" sz="950" dirty="0"/>
+          </a:p>
+        </p:txBody>
+      </p:sp>
+      <p:sp>
+        <p:nvSpPr>
+          <p:cNvPr id="67" name="Shape 65"/>
+          <p:cNvSpPr/>
+          <p:nvPr/>
+        </p:nvSpPr>
+        <p:spPr>
+          <a:xfrm>
+            <a:off x="7818120" y="5047488"/>
+            <a:ext cx="3840480" cy="0"/>
+          </a:xfrm>
+          <a:prstGeom prst="line">
+            <a:avLst/>
+          </a:prstGeom>
+          <a:noFill/>
+          <a:ln w="6350">
+            <a:solidFill>
+              <a:srgbClr val="222233"/>
+            </a:solidFill>
+            <a:prstDash val="solid"/>
+          </a:ln>
+        </p:spPr>
+      </p:sp>
+      <p:sp>
+        <p:nvSpPr>
+          <p:cNvPr id="68" name="Text 66"/>
+          <p:cNvSpPr/>
+          <p:nvPr/>
+        </p:nvSpPr>
+        <p:spPr>
+          <a:xfrm>
+            <a:off x="7818120" y="5084064"/>
+            <a:ext cx="1828800" cy="347472"/>
+          </a:xfrm>
+          <a:prstGeom prst="rect">
+            <a:avLst/>
+          </a:prstGeom>
+          <a:noFill/>
+          <a:ln/>
+        </p:spPr>
+        <p:txBody>
+          <a:bodyPr wrap="square" rtlCol="0" anchor="ctr"/>
+          <a:lstStyle/>
+          <a:p>
+            <a:pPr indent="0" marL="0">
+              <a:buNone/>
+            </a:pPr>
+            <a:r>
+              <a:rPr lang="en-US" sz="950" dirty="0">
+                <a:solidFill>
+                  <a:srgbClr val="8899CC"/>
+                </a:solidFill>
+                <a:latin typeface="Calibri" pitchFamily="34" charset="0"/>
+                <a:ea typeface="Calibri" pitchFamily="34" charset="-122"/>
+                <a:cs typeface="Calibri" pitchFamily="34" charset="-120"/>
+              </a:rPr>
+              <a:t>Temperature</a:t>
+            </a:r>
+            <a:endParaRPr lang="en-US" sz="950" dirty="0"/>
+          </a:p>
+        </p:txBody>
+      </p:sp>
+      <p:sp>
+        <p:nvSpPr>
+          <p:cNvPr id="69" name="Text 67"/>
+          <p:cNvSpPr/>
+          <p:nvPr/>
+        </p:nvSpPr>
+        <p:spPr>
+          <a:xfrm>
+            <a:off x="9692640" y="5084064"/>
+            <a:ext cx="2011680" cy="347472"/>
+          </a:xfrm>
+          <a:prstGeom prst="rect">
+            <a:avLst/>
+          </a:prstGeom>
+          <a:noFill/>
+          <a:ln/>
+        </p:spPr>
+        <p:txBody>
+          <a:bodyPr wrap="square" rtlCol="0" anchor="ctr"/>
+          <a:lstStyle/>
+          <a:p>
+            <a:pPr indent="0" marL="0">
+              <a:buNone/>
+            </a:pPr>
+            <a:r>
+              <a:rPr lang="en-US" sz="950" b="1" dirty="0">
+                <a:solidFill>
+                  <a:srgbClr val="FFFFFF"/>
+                </a:solidFill>
+                <a:latin typeface="Calibri" pitchFamily="34" charset="0"/>
+                <a:ea typeface="Calibri" pitchFamily="34" charset="-122"/>
+                <a:cs typeface="Calibri" pitchFamily="34" charset="-120"/>
+              </a:rPr>
+              <a:t>0.7</a:t>
+            </a:r>
+            <a:endParaRPr lang="en-US" sz="950" dirty="0"/>
+          </a:p>
+        </p:txBody>
+      </p:sp>
+      <p:sp>
+        <p:nvSpPr>
+          <p:cNvPr id="70" name="Shape 68"/>
+          <p:cNvSpPr/>
+          <p:nvPr/>
+        </p:nvSpPr>
+        <p:spPr>
+          <a:xfrm>
+            <a:off x="7818120" y="5431536"/>
+            <a:ext cx="3840480" cy="0"/>
+          </a:xfrm>
+          <a:prstGeom prst="line">
+            <a:avLst/>
+          </a:prstGeom>
+          <a:noFill/>
+          <a:ln w="6350">
+            <a:solidFill>
+              <a:srgbClr val="222233"/>
+            </a:solidFill>
+            <a:prstDash val="solid"/>
+          </a:ln>
+        </p:spPr>
+      </p:sp>
+      <p:sp>
+        <p:nvSpPr>
+          <p:cNvPr id="71" name="Text 69"/>
+          <p:cNvSpPr/>
+          <p:nvPr/>
+        </p:nvSpPr>
+        <p:spPr>
+          <a:xfrm>
+            <a:off x="7818120" y="5468112"/>
+            <a:ext cx="1828800" cy="347472"/>
+          </a:xfrm>
+          <a:prstGeom prst="rect">
+            <a:avLst/>
+          </a:prstGeom>
+          <a:noFill/>
+          <a:ln/>
+        </p:spPr>
+        <p:txBody>
+          <a:bodyPr wrap="square" rtlCol="0" anchor="ctr"/>
+          <a:lstStyle/>
+          <a:p>
+            <a:pPr indent="0" marL="0">
+              <a:buNone/>
+            </a:pPr>
+            <a:r>
+              <a:rPr lang="en-US" sz="950" dirty="0">
+                <a:solidFill>
+                  <a:srgbClr val="8899CC"/>
+                </a:solidFill>
+                <a:latin typeface="Calibri" pitchFamily="34" charset="0"/>
+                <a:ea typeface="Calibri" pitchFamily="34" charset="-122"/>
+                <a:cs typeface="Calibri" pitchFamily="34" charset="-120"/>
+              </a:rPr>
+              <a:t>Top P</a:t>
+            </a:r>
+            <a:endParaRPr lang="en-US" sz="950" dirty="0"/>
+          </a:p>
+        </p:txBody>
+      </p:sp>
+      <p:sp>
+        <p:nvSpPr>
+          <p:cNvPr id="72" name="Text 70"/>
+          <p:cNvSpPr/>
+          <p:nvPr/>
+        </p:nvSpPr>
+        <p:spPr>
+          <a:xfrm>
+            <a:off x="9692640" y="5468112"/>
+            <a:ext cx="2011680" cy="347472"/>
+          </a:xfrm>
+          <a:prstGeom prst="rect">
+            <a:avLst/>
+          </a:prstGeom>
+          <a:noFill/>
+          <a:ln/>
+        </p:spPr>
+        <p:txBody>
+          <a:bodyPr wrap="square" rtlCol="0" anchor="ctr"/>
+          <a:lstStyle/>
+          <a:p>
+            <a:pPr indent="0" marL="0">
+              <a:buNone/>
+            </a:pPr>
+            <a:r>
+              <a:rPr lang="en-US" sz="950" b="1" dirty="0">
+                <a:solidFill>
+                  <a:srgbClr val="FFFFFF"/>
+                </a:solidFill>
+                <a:latin typeface="Calibri" pitchFamily="34" charset="0"/>
+                <a:ea typeface="Calibri" pitchFamily="34" charset="-122"/>
+                <a:cs typeface="Calibri" pitchFamily="34" charset="-120"/>
+              </a:rPr>
+              <a:t>0.9</a:t>
+            </a:r>
+            <a:endParaRPr lang="en-US" sz="950" dirty="0"/>
+          </a:p>
+        </p:txBody>
+      </p:sp>
+      <p:sp>
+        <p:nvSpPr>
+          <p:cNvPr id="73" name="Shape 71"/>
+          <p:cNvSpPr/>
+          <p:nvPr/>
+        </p:nvSpPr>
+        <p:spPr>
+          <a:xfrm>
+            <a:off x="7818120" y="5815584"/>
+            <a:ext cx="3840480" cy="0"/>
+          </a:xfrm>
+          <a:prstGeom prst="line">
+            <a:avLst/>
+          </a:prstGeom>
+          <a:noFill/>
+          <a:ln w="6350">
+            <a:solidFill>
+              <a:srgbClr val="222233"/>
+            </a:solidFill>
+            <a:prstDash val="solid"/>
+          </a:ln>
+        </p:spPr>
+      </p:sp>
+      <p:sp>
+        <p:nvSpPr>
+          <p:cNvPr id="74" name="Text 72"/>
+          <p:cNvSpPr/>
+          <p:nvPr/>
+        </p:nvSpPr>
+        <p:spPr>
+          <a:xfrm>
+            <a:off x="7818120" y="5852160"/>
+            <a:ext cx="1828800" cy="347472"/>
+          </a:xfrm>
+          <a:prstGeom prst="rect">
+            <a:avLst/>
+          </a:prstGeom>
+          <a:noFill/>
+          <a:ln/>
+        </p:spPr>
+        <p:txBody>
+          <a:bodyPr wrap="square" rtlCol="0" anchor="ctr"/>
+          <a:lstStyle/>
+          <a:p>
+            <a:pPr indent="0" marL="0">
+              <a:buNone/>
+            </a:pPr>
+            <a:r>
+              <a:rPr lang="en-US" sz="950" dirty="0">
+                <a:solidFill>
+                  <a:srgbClr val="8899CC"/>
+                </a:solidFill>
+                <a:latin typeface="Calibri" pitchFamily="34" charset="0"/>
+                <a:ea typeface="Calibri" pitchFamily="34" charset="-122"/>
+                <a:cs typeface="Calibri" pitchFamily="34" charset="-120"/>
+              </a:rPr>
+              <a:t>Repetition Penalty</a:t>
+            </a:r>
+            <a:endParaRPr lang="en-US" sz="950" dirty="0"/>
+          </a:p>
+        </p:txBody>
+      </p:sp>
+      <p:sp>
+        <p:nvSpPr>
+          <p:cNvPr id="75" name="Text 73"/>
+          <p:cNvSpPr/>
+          <p:nvPr/>
+        </p:nvSpPr>
+        <p:spPr>
+          <a:xfrm>
+            <a:off x="9692640" y="5852160"/>
+            <a:ext cx="2011680" cy="347472"/>
+          </a:xfrm>
+          <a:prstGeom prst="rect">
+            <a:avLst/>
+          </a:prstGeom>
+          <a:noFill/>
+          <a:ln/>
+        </p:spPr>
+        <p:txBody>
+          <a:bodyPr wrap="square" rtlCol="0" anchor="ctr"/>
+          <a:lstStyle/>
+          <a:p>
+            <a:pPr indent="0" marL="0">
+              <a:buNone/>
+            </a:pPr>
+            <a:r>
+              <a:rPr lang="en-US" sz="950" b="1" dirty="0">
+                <a:solidFill>
+                  <a:srgbClr val="FFFFFF"/>
+                </a:solidFill>
+                <a:latin typeface="Calibri" pitchFamily="34" charset="0"/>
+                <a:ea typeface="Calibri" pitchFamily="34" charset="-122"/>
+                <a:cs typeface="Calibri" pitchFamily="34" charset="-120"/>
+              </a:rPr>
+              <a:t>1.1</a:t>
+            </a:r>
+            <a:endParaRPr lang="en-US" sz="950" dirty="0"/>
+          </a:p>
+        </p:txBody>
+      </p:sp>
+      <p:sp>
+        <p:nvSpPr>
+          <p:cNvPr id="76" name="Shape 74"/>
+          <p:cNvSpPr/>
+          <p:nvPr/>
+        </p:nvSpPr>
+        <p:spPr>
+          <a:xfrm>
+            <a:off x="7818120" y="6199632"/>
+            <a:ext cx="3840480" cy="0"/>
+          </a:xfrm>
+          <a:prstGeom prst="line">
+            <a:avLst/>
+          </a:prstGeom>
+          <a:noFill/>
+          <a:ln w="6350">
+            <a:solidFill>
+              <a:srgbClr val="222233"/>
+            </a:solidFill>
+            <a:prstDash val="solid"/>
+          </a:ln>
+        </p:spPr>
+      </p:sp>
+      <p:sp>
+        <p:nvSpPr>
+          <p:cNvPr id="77" name="Text 75"/>
+          <p:cNvSpPr/>
+          <p:nvPr/>
+        </p:nvSpPr>
+        <p:spPr>
+          <a:xfrm>
+            <a:off x="7818120" y="6236208"/>
+            <a:ext cx="1828800" cy="347472"/>
+          </a:xfrm>
+          <a:prstGeom prst="rect">
+            <a:avLst/>
+          </a:prstGeom>
+          <a:noFill/>
+          <a:ln/>
+        </p:spPr>
+        <p:txBody>
+          <a:bodyPr wrap="square" rtlCol="0" anchor="ctr"/>
+          <a:lstStyle/>
+          <a:p>
+            <a:pPr indent="0" marL="0">
+              <a:buNone/>
+            </a:pPr>
+            <a:r>
+              <a:rPr lang="en-US" sz="950" dirty="0">
+                <a:solidFill>
+                  <a:srgbClr val="8899CC"/>
+                </a:solidFill>
+                <a:latin typeface="Calibri" pitchFamily="34" charset="0"/>
+                <a:ea typeface="Calibri" pitchFamily="34" charset="-122"/>
+                <a:cs typeface="Calibri" pitchFamily="34" charset="-120"/>
+              </a:rPr>
+              <a:t>Decoding</a:t>
+            </a:r>
+            <a:endParaRPr lang="en-US" sz="950" dirty="0"/>
+          </a:p>
+        </p:txBody>
+      </p:sp>
+      <p:sp>
+        <p:nvSpPr>
+          <p:cNvPr id="78" name="Text 76"/>
+          <p:cNvSpPr/>
+          <p:nvPr/>
+        </p:nvSpPr>
+        <p:spPr>
+          <a:xfrm>
+            <a:off x="9692640" y="6236208"/>
+            <a:ext cx="2011680" cy="347472"/>
+          </a:xfrm>
+          <a:prstGeom prst="rect">
+            <a:avLst/>
+          </a:prstGeom>
+          <a:noFill/>
+          <a:ln/>
+        </p:spPr>
+        <p:txBody>
+          <a:bodyPr wrap="square" rtlCol="0" anchor="ctr"/>
+          <a:lstStyle/>
+          <a:p>
+            <a:pPr indent="0" marL="0">
+              <a:buNone/>
+            </a:pPr>
+            <a:r>
+              <a:rPr lang="en-US" sz="950" b="1" dirty="0">
+                <a:solidFill>
+                  <a:srgbClr val="FFFFFF"/>
+                </a:solidFill>
+                <a:latin typeface="Calibri" pitchFamily="34" charset="0"/>
+                <a:ea typeface="Calibri" pitchFamily="34" charset="-122"/>
+                <a:cs typeface="Calibri" pitchFamily="34" charset="-120"/>
+              </a:rPr>
+              <a:t>Greedy / Sampling</a:t>
+            </a:r>
+            <a:endParaRPr lang="en-US" sz="950" dirty="0"/>
+          </a:p>
+        </p:txBody>
+      </p:sp>
+      <p:sp>
+        <p:nvSpPr>
+          <p:cNvPr id="79" name="Text 77"/>
+          <p:cNvSpPr/>
+          <p:nvPr/>
+        </p:nvSpPr>
+        <p:spPr>
+          <a:xfrm>
+            <a:off x="320040" y="6492240"/>
+            <a:ext cx="11521440" cy="256032"/>
+          </a:xfrm>
+          <a:prstGeom prst="rect">
+            <a:avLst/>
+          </a:prstGeom>
+          <a:noFill/>
+          <a:ln/>
+        </p:spPr>
+        <p:txBody>
+          <a:bodyPr wrap="square" rtlCol="0" anchor="ctr"/>
+          <a:lstStyle/>
+          <a:p>
+            <a:pPr algn="ctr" indent="0" marL="0">
+              <a:buNone/>
+            </a:pPr>
+            <a:r>
               <a:rPr lang="en-US" sz="850" i="1" dirty="0">
                 <a:solidFill>
-                  <a:srgbClr val="6F6F6F"/>
-                </a:solidFill>
-                <a:latin typeface="Calibri" pitchFamily="34" charset="0"/>
-                <a:ea typeface="Calibri" pitchFamily="34" charset="-122"/>
-                <a:cs typeface="Calibri" pitchFamily="34" charset="-120"/>
-              </a:rPr>
-              <a:t>ℹ️  Run the flow once in LangFlow, then replace the boxes above with before/after token usage screenshots from the LangFlow logs panel.</a:t>
+                  <a:srgbClr val="556677"/>
+                </a:solidFill>
+                <a:latin typeface="Calibri" pitchFamily="34" charset="0"/>
+                <a:ea typeface="Calibri" pitchFamily="34" charset="-122"/>
+                <a:cs typeface="Calibri" pitchFamily="34" charset="-120"/>
+              </a:rPr>
+              <a:t>Multi-turn sessions accumulate tokens — 4 agents × avg 2,761 tokens/call = ~11,044 tokens per full session</a:t>
             </a:r>
             <a:endParaRPr lang="en-US" sz="850" dirty="0"/>
           </a:p>
@@ -5950,555 +8115,6 @@
 <file path=ppt/slides/slide14.xml><?xml version="1.0" encoding="utf-8"?>
 <p:sld xmlns:a="http://schemas.openxmlformats.org/drawingml/2006/main" xmlns:r="http://schemas.openxmlformats.org/officeDocument/2006/relationships" xmlns:p="http://schemas.openxmlformats.org/presentationml/2006/main">
   <p:cSld name="Slide 14">
-    <p:spTree>
-      <p:nvGrpSpPr>
-        <p:cNvPr id="1" name=""/>
-        <p:cNvGrpSpPr/>
-        <p:nvPr/>
-      </p:nvGrpSpPr>
-      <p:grpSpPr>
-        <a:xfrm>
-          <a:off x="0" y="0"/>
-          <a:ext cx="0" cy="0"/>
-          <a:chOff x="0" y="0"/>
-          <a:chExt cx="0" cy="0"/>
-        </a:xfrm>
-      </p:grpSpPr>
-      <p:sp>
-        <p:nvSpPr>
-          <p:cNvPr id="2" name="Shape 0"/>
-          <p:cNvSpPr/>
-          <p:nvPr/>
-        </p:nvSpPr>
-        <p:spPr>
-          <a:xfrm>
-            <a:off x="0" y="0"/>
-            <a:ext cx="12161520" cy="6858000"/>
-          </a:xfrm>
-          <a:prstGeom prst="rect">
-            <a:avLst/>
-          </a:prstGeom>
-          <a:solidFill>
-            <a:srgbClr val="F4F4F4"/>
-          </a:solidFill>
-          <a:ln/>
-        </p:spPr>
-      </p:sp>
-      <p:sp>
-        <p:nvSpPr>
-          <p:cNvPr id="3" name="Shape 1"/>
-          <p:cNvSpPr/>
-          <p:nvPr/>
-        </p:nvSpPr>
-        <p:spPr>
-          <a:xfrm>
-            <a:off x="0" y="0"/>
-            <a:ext cx="12161520" cy="777240"/>
-          </a:xfrm>
-          <a:prstGeom prst="rect">
-            <a:avLst/>
-          </a:prstGeom>
-          <a:solidFill>
-            <a:srgbClr val="0F62FE"/>
-          </a:solidFill>
-          <a:ln/>
-        </p:spPr>
-      </p:sp>
-      <p:sp>
-        <p:nvSpPr>
-          <p:cNvPr id="4" name="Text 2"/>
-          <p:cNvSpPr/>
-          <p:nvPr/>
-        </p:nvSpPr>
-        <p:spPr>
-          <a:xfrm>
-            <a:off x="274320" y="137160"/>
-            <a:ext cx="11612880" cy="548640"/>
-          </a:xfrm>
-          <a:prstGeom prst="rect">
-            <a:avLst/>
-          </a:prstGeom>
-          <a:noFill/>
-          <a:ln/>
-        </p:spPr>
-        <p:txBody>
-          <a:bodyPr wrap="square" rtlCol="0" anchor="ctr"/>
-          <a:lstStyle/>
-          <a:p>
-            <a:pPr indent="0" marL="0">
-              <a:buNone/>
-            </a:pPr>
-            <a:r>
-              <a:rPr lang="en-US" sz="2200" b="1" dirty="0">
-                <a:solidFill>
-                  <a:srgbClr val="FFFFFF"/>
-                </a:solidFill>
-                <a:latin typeface="Calibri" pitchFamily="34" charset="0"/>
-                <a:ea typeface="Calibri" pitchFamily="34" charset="-122"/>
-                <a:cs typeface="Calibri" pitchFamily="34" charset="-120"/>
-              </a:rPr>
-              <a:t>Certificates Earned</a:t>
-            </a:r>
-            <a:endParaRPr lang="en-US" sz="2200" dirty="0"/>
-          </a:p>
-        </p:txBody>
-      </p:sp>
-      <p:sp>
-        <p:nvSpPr>
-          <p:cNvPr id="5" name="Shape 3"/>
-          <p:cNvSpPr/>
-          <p:nvPr/>
-        </p:nvSpPr>
-        <p:spPr>
-          <a:xfrm>
-            <a:off x="914400" y="1005840"/>
-            <a:ext cx="10332720" cy="5029200"/>
-          </a:xfrm>
-          <a:prstGeom prst="roundRect">
-            <a:avLst>
-              <a:gd name="adj" fmla="val 2182"/>
-            </a:avLst>
-          </a:prstGeom>
-          <a:solidFill>
-            <a:srgbClr val="FFFFFF"/>
-          </a:solidFill>
-          <a:ln/>
-        </p:spPr>
-      </p:sp>
-      <p:sp>
-        <p:nvSpPr>
-          <p:cNvPr id="6" name="Text 4"/>
-          <p:cNvSpPr/>
-          <p:nvPr/>
-        </p:nvSpPr>
-        <p:spPr>
-          <a:xfrm>
-            <a:off x="914400" y="1005840"/>
-            <a:ext cx="10332720" cy="5029200"/>
-          </a:xfrm>
-          <a:prstGeom prst="rect">
-            <a:avLst/>
-          </a:prstGeom>
-          <a:noFill/>
-          <a:ln/>
-        </p:spPr>
-        <p:txBody>
-          <a:bodyPr wrap="square" rtlCol="0" anchor="ctr"/>
-          <a:lstStyle/>
-          <a:p>
-            <a:pPr algn="ctr" indent="0" marL="0">
-              <a:buNone/>
-            </a:pPr>
-            <a:r>
-              <a:rPr lang="en-US" sz="1600" dirty="0">
-                <a:solidFill>
-                  <a:srgbClr val="6F6F6F"/>
-                </a:solidFill>
-                <a:latin typeface="Calibri" pitchFamily="34" charset="0"/>
-                <a:ea typeface="Calibri" pitchFamily="34" charset="-122"/>
-                <a:cs typeface="Calibri" pitchFamily="34" charset="-120"/>
-              </a:rPr>
-              <a:t>📸  Add your IBM SkillsBuild / Credly Certificate here</a:t>
-            </a:r>
-            <a:endParaRPr lang="en-US" sz="1600" dirty="0"/>
-          </a:p>
-        </p:txBody>
-      </p:sp>
-      <p:sp>
-        <p:nvSpPr>
-          <p:cNvPr id="7" name="Text 5"/>
-          <p:cNvSpPr/>
-          <p:nvPr/>
-        </p:nvSpPr>
-        <p:spPr>
-          <a:xfrm>
-            <a:off x="1371600" y="5029200"/>
-            <a:ext cx="9418320" cy="777240"/>
-          </a:xfrm>
-          <a:prstGeom prst="rect">
-            <a:avLst/>
-          </a:prstGeom>
-          <a:noFill/>
-          <a:ln/>
-        </p:spPr>
-        <p:txBody>
-          <a:bodyPr wrap="square" rtlCol="0" anchor="ctr"/>
-          <a:lstStyle/>
-          <a:p>
-            <a:pPr algn="ctr" indent="0" marL="0">
-              <a:lnSpc>
-                <a:spcPct val="150000"/>
-              </a:lnSpc>
-              <a:buNone/>
-            </a:pPr>
-            <a:r>
-              <a:rPr lang="en-US" sz="1000" i="1" dirty="0">
-                <a:solidFill>
-                  <a:srgbClr val="6F6F6F"/>
-                </a:solidFill>
-                <a:latin typeface="Calibri" pitchFamily="34" charset="0"/>
-                <a:ea typeface="Calibri" pitchFamily="34" charset="-122"/>
-                <a:cs typeface="Calibri" pitchFamily="34" charset="-120"/>
-              </a:rPr>
-              <a:t>Go to: credly.com → Your Badges → Share → Copy Image → Paste here</a:t>
-            </a:r>
-            <a:endParaRPr lang="en-US" sz="1000" dirty="0"/>
-          </a:p>
-          <a:p>
-            <a:pPr algn="ctr" indent="0" marL="0">
-              <a:lnSpc>
-                <a:spcPct val="150000"/>
-              </a:lnSpc>
-              <a:buNone/>
-            </a:pPr>
-            <a:r>
-              <a:rPr lang="en-US" sz="1000" i="1" dirty="0">
-                <a:solidFill>
-                  <a:srgbClr val="6F6F6F"/>
-                </a:solidFill>
-                <a:latin typeface="Calibri" pitchFamily="34" charset="0"/>
-                <a:ea typeface="Calibri" pitchFamily="34" charset="-122"/>
-                <a:cs typeface="Calibri" pitchFamily="34" charset="-120"/>
-              </a:rPr>
-              <a:t>OR: skillsbuild.org → My Achievements → Screenshot the certificate</a:t>
-            </a:r>
-            <a:endParaRPr lang="en-US" sz="1000" dirty="0"/>
-          </a:p>
-        </p:txBody>
-      </p:sp>
-      <p:sp>
-        <p:nvSpPr>
-          <p:cNvPr id="8" name="Shape 6"/>
-          <p:cNvSpPr/>
-          <p:nvPr/>
-        </p:nvSpPr>
-        <p:spPr>
-          <a:xfrm>
-            <a:off x="0" y="6492240"/>
-            <a:ext cx="12161520" cy="365760"/>
-          </a:xfrm>
-          <a:prstGeom prst="rect">
-            <a:avLst/>
-          </a:prstGeom>
-          <a:solidFill>
-            <a:srgbClr val="0F62FE"/>
-          </a:solidFill>
-          <a:ln/>
-        </p:spPr>
-      </p:sp>
-      <p:sp>
-        <p:nvSpPr>
-          <p:cNvPr id="9" name="Text 7"/>
-          <p:cNvSpPr/>
-          <p:nvPr/>
-        </p:nvSpPr>
-        <p:spPr>
-          <a:xfrm>
-            <a:off x="182880" y="6510528"/>
-            <a:ext cx="11795760" cy="292608"/>
-          </a:xfrm>
-          <a:prstGeom prst="rect">
-            <a:avLst/>
-          </a:prstGeom>
-          <a:noFill/>
-          <a:ln/>
-        </p:spPr>
-        <p:txBody>
-          <a:bodyPr wrap="square" rtlCol="0" anchor="ctr"/>
-          <a:lstStyle/>
-          <a:p>
-            <a:pPr algn="ctr" indent="0" marL="0">
-              <a:buNone/>
-            </a:pPr>
-            <a:r>
-              <a:rPr lang="en-US" sz="750" dirty="0">
-                <a:solidFill>
-                  <a:srgbClr val="FFFFFF"/>
-                </a:solidFill>
-                <a:latin typeface="Calibri" pitchFamily="34" charset="0"/>
-                <a:ea typeface="Calibri" pitchFamily="34" charset="-122"/>
-                <a:cs typeface="Calibri" pitchFamily="34" charset="-120"/>
-              </a:rPr>
-              <a:t>AI Nutrition Agent  |  IBM watsonx.ai + LangFlow  |  Aman Raj  |  Edunet Foundation × IBM SkillsBuild</a:t>
-            </a:r>
-            <a:endParaRPr lang="en-US" sz="750" dirty="0"/>
-          </a:p>
-        </p:txBody>
-      </p:sp>
-    </p:spTree>
-  </p:cSld>
-  <p:clrMapOvr>
-    <a:masterClrMapping/>
-  </p:clrMapOvr>
-</p:sld>
-</file>
-
-<file path=ppt/slides/slide15.xml><?xml version="1.0" encoding="utf-8"?>
-<p:sld xmlns:a="http://schemas.openxmlformats.org/drawingml/2006/main" xmlns:r="http://schemas.openxmlformats.org/officeDocument/2006/relationships" xmlns:p="http://schemas.openxmlformats.org/presentationml/2006/main">
-  <p:cSld name="Slide 15">
-    <p:spTree>
-      <p:nvGrpSpPr>
-        <p:cNvPr id="1" name=""/>
-        <p:cNvGrpSpPr/>
-        <p:nvPr/>
-      </p:nvGrpSpPr>
-      <p:grpSpPr>
-        <a:xfrm>
-          <a:off x="0" y="0"/>
-          <a:ext cx="0" cy="0"/>
-          <a:chOff x="0" y="0"/>
-          <a:chExt cx="0" cy="0"/>
-        </a:xfrm>
-      </p:grpSpPr>
-      <p:sp>
-        <p:nvSpPr>
-          <p:cNvPr id="2" name="Shape 0"/>
-          <p:cNvSpPr/>
-          <p:nvPr/>
-        </p:nvSpPr>
-        <p:spPr>
-          <a:xfrm>
-            <a:off x="0" y="0"/>
-            <a:ext cx="12161520" cy="6858000"/>
-          </a:xfrm>
-          <a:prstGeom prst="rect">
-            <a:avLst/>
-          </a:prstGeom>
-          <a:solidFill>
-            <a:srgbClr val="F4F4F4"/>
-          </a:solidFill>
-          <a:ln/>
-        </p:spPr>
-      </p:sp>
-      <p:sp>
-        <p:nvSpPr>
-          <p:cNvPr id="3" name="Shape 1"/>
-          <p:cNvSpPr/>
-          <p:nvPr/>
-        </p:nvSpPr>
-        <p:spPr>
-          <a:xfrm>
-            <a:off x="0" y="0"/>
-            <a:ext cx="12161520" cy="777240"/>
-          </a:xfrm>
-          <a:prstGeom prst="rect">
-            <a:avLst/>
-          </a:prstGeom>
-          <a:solidFill>
-            <a:srgbClr val="161616"/>
-          </a:solidFill>
-          <a:ln/>
-        </p:spPr>
-      </p:sp>
-      <p:sp>
-        <p:nvSpPr>
-          <p:cNvPr id="4" name="Text 2"/>
-          <p:cNvSpPr/>
-          <p:nvPr/>
-        </p:nvSpPr>
-        <p:spPr>
-          <a:xfrm>
-            <a:off x="274320" y="137160"/>
-            <a:ext cx="11612880" cy="548640"/>
-          </a:xfrm>
-          <a:prstGeom prst="rect">
-            <a:avLst/>
-          </a:prstGeom>
-          <a:noFill/>
-          <a:ln/>
-        </p:spPr>
-        <p:txBody>
-          <a:bodyPr wrap="square" rtlCol="0" anchor="ctr"/>
-          <a:lstStyle/>
-          <a:p>
-            <a:pPr indent="0" marL="0">
-              <a:buNone/>
-            </a:pPr>
-            <a:r>
-              <a:rPr lang="en-US" sz="2200" b="1" dirty="0">
-                <a:solidFill>
-                  <a:srgbClr val="FFFFFF"/>
-                </a:solidFill>
-                <a:latin typeface="Calibri" pitchFamily="34" charset="0"/>
-                <a:ea typeface="Calibri" pitchFamily="34" charset="-122"/>
-                <a:cs typeface="Calibri" pitchFamily="34" charset="-120"/>
-              </a:rPr>
-              <a:t>IBM SkillsBuild Certificate</a:t>
-            </a:r>
-            <a:endParaRPr lang="en-US" sz="2200" dirty="0"/>
-          </a:p>
-        </p:txBody>
-      </p:sp>
-      <p:sp>
-        <p:nvSpPr>
-          <p:cNvPr id="5" name="Shape 3"/>
-          <p:cNvSpPr/>
-          <p:nvPr/>
-        </p:nvSpPr>
-        <p:spPr>
-          <a:xfrm>
-            <a:off x="914400" y="1005840"/>
-            <a:ext cx="10332720" cy="5029200"/>
-          </a:xfrm>
-          <a:prstGeom prst="roundRect">
-            <a:avLst>
-              <a:gd name="adj" fmla="val 2182"/>
-            </a:avLst>
-          </a:prstGeom>
-          <a:solidFill>
-            <a:srgbClr val="FFFFFF"/>
-          </a:solidFill>
-          <a:ln/>
-        </p:spPr>
-      </p:sp>
-      <p:sp>
-        <p:nvSpPr>
-          <p:cNvPr id="6" name="Text 4"/>
-          <p:cNvSpPr/>
-          <p:nvPr/>
-        </p:nvSpPr>
-        <p:spPr>
-          <a:xfrm>
-            <a:off x="914400" y="1005840"/>
-            <a:ext cx="10332720" cy="5029200"/>
-          </a:xfrm>
-          <a:prstGeom prst="rect">
-            <a:avLst/>
-          </a:prstGeom>
-          <a:noFill/>
-          <a:ln/>
-        </p:spPr>
-        <p:txBody>
-          <a:bodyPr wrap="square" rtlCol="0" anchor="ctr"/>
-          <a:lstStyle/>
-          <a:p>
-            <a:pPr algn="ctr" indent="0" marL="0">
-              <a:buNone/>
-            </a:pPr>
-            <a:r>
-              <a:rPr lang="en-US" sz="1600" dirty="0">
-                <a:solidFill>
-                  <a:srgbClr val="6F6F6F"/>
-                </a:solidFill>
-                <a:latin typeface="Calibri" pitchFamily="34" charset="0"/>
-                <a:ea typeface="Calibri" pitchFamily="34" charset="-122"/>
-                <a:cs typeface="Calibri" pitchFamily="34" charset="-120"/>
-              </a:rPr>
-              <a:t>📸  Add your IBM BOB (Build on Base) Certificate here</a:t>
-            </a:r>
-            <a:endParaRPr lang="en-US" sz="1600" dirty="0"/>
-          </a:p>
-        </p:txBody>
-      </p:sp>
-      <p:sp>
-        <p:nvSpPr>
-          <p:cNvPr id="7" name="Text 5"/>
-          <p:cNvSpPr/>
-          <p:nvPr/>
-        </p:nvSpPr>
-        <p:spPr>
-          <a:xfrm>
-            <a:off x="1371600" y="5029200"/>
-            <a:ext cx="9418320" cy="777240"/>
-          </a:xfrm>
-          <a:prstGeom prst="rect">
-            <a:avLst/>
-          </a:prstGeom>
-          <a:noFill/>
-          <a:ln/>
-        </p:spPr>
-        <p:txBody>
-          <a:bodyPr wrap="square" rtlCol="0" anchor="ctr"/>
-          <a:lstStyle/>
-          <a:p>
-            <a:pPr algn="ctr" indent="0" marL="0">
-              <a:buNone/>
-            </a:pPr>
-            <a:r>
-              <a:rPr lang="en-US" sz="1000" i="1" dirty="0">
-                <a:solidFill>
-                  <a:srgbClr val="6F6F6F"/>
-                </a:solidFill>
-                <a:latin typeface="Calibri" pitchFamily="34" charset="0"/>
-                <a:ea typeface="Calibri" pitchFamily="34" charset="-122"/>
-                <a:cs typeface="Calibri" pitchFamily="34" charset="-120"/>
-              </a:rPr>
-              <a:t>Download from: IBM SkillsBuild Dashboard → My Learning → Completed → Download Certificate</a:t>
-            </a:r>
-            <a:endParaRPr lang="en-US" sz="1000" dirty="0"/>
-          </a:p>
-        </p:txBody>
-      </p:sp>
-      <p:sp>
-        <p:nvSpPr>
-          <p:cNvPr id="8" name="Shape 6"/>
-          <p:cNvSpPr/>
-          <p:nvPr/>
-        </p:nvSpPr>
-        <p:spPr>
-          <a:xfrm>
-            <a:off x="0" y="6492240"/>
-            <a:ext cx="12161520" cy="365760"/>
-          </a:xfrm>
-          <a:prstGeom prst="rect">
-            <a:avLst/>
-          </a:prstGeom>
-          <a:solidFill>
-            <a:srgbClr val="0F62FE"/>
-          </a:solidFill>
-          <a:ln/>
-        </p:spPr>
-      </p:sp>
-      <p:sp>
-        <p:nvSpPr>
-          <p:cNvPr id="9" name="Text 7"/>
-          <p:cNvSpPr/>
-          <p:nvPr/>
-        </p:nvSpPr>
-        <p:spPr>
-          <a:xfrm>
-            <a:off x="182880" y="6510528"/>
-            <a:ext cx="11795760" cy="292608"/>
-          </a:xfrm>
-          <a:prstGeom prst="rect">
-            <a:avLst/>
-          </a:prstGeom>
-          <a:noFill/>
-          <a:ln/>
-        </p:spPr>
-        <p:txBody>
-          <a:bodyPr wrap="square" rtlCol="0" anchor="ctr"/>
-          <a:lstStyle/>
-          <a:p>
-            <a:pPr algn="ctr" indent="0" marL="0">
-              <a:buNone/>
-            </a:pPr>
-            <a:r>
-              <a:rPr lang="en-US" sz="750" dirty="0">
-                <a:solidFill>
-                  <a:srgbClr val="FFFFFF"/>
-                </a:solidFill>
-                <a:latin typeface="Calibri" pitchFamily="34" charset="0"/>
-                <a:ea typeface="Calibri" pitchFamily="34" charset="-122"/>
-                <a:cs typeface="Calibri" pitchFamily="34" charset="-120"/>
-              </a:rPr>
-              <a:t>AI Nutrition Agent  |  IBM watsonx.ai + LangFlow  |  Aman Raj  |  Edunet Foundation × IBM SkillsBuild</a:t>
-            </a:r>
-            <a:endParaRPr lang="en-US" sz="750" dirty="0"/>
-          </a:p>
-        </p:txBody>
-      </p:sp>
-    </p:spTree>
-  </p:cSld>
-  <p:clrMapOvr>
-    <a:masterClrMapping/>
-  </p:clrMapOvr>
-</p:sld>
-</file>
-
-<file path=ppt/slides/slide16.xml><?xml version="1.0" encoding="utf-8"?>
-<p:sld xmlns:a="http://schemas.openxmlformats.org/drawingml/2006/main" xmlns:r="http://schemas.openxmlformats.org/officeDocument/2006/relationships" xmlns:p="http://schemas.openxmlformats.org/presentationml/2006/main">
-  <p:cSld name="Slide 16">
     <p:spTree>
       <p:nvGrpSpPr>
         <p:cNvPr id="1" name=""/>

</xml_diff>